<commit_message>
Redraw the slide figures in R: Arial, the distribution behind every summary, bootstrap 95% CIs and the test printed on the panel
Co-Authored-By: Claude Opus 5 <noreply@anthropic.com>
</commit_message>
<xml_diff>
--- a/Analysis/AP1_fibroblast_lab_meeting.pptx
+++ b/Analysis/AP1_fibroblast_lab_meeting.pptx
@@ -2425,8 +2425,8 @@
         </p:nvSpPr>
         <p:spPr>
           <a:xfrm>
-            <a:off x="502920" y="987552"/>
-            <a:ext cx="11155680" cy="292608"/>
+            <a:off x="502920" y="969264"/>
+            <a:ext cx="11155680" cy="310896"/>
           </a:xfrm>
           <a:prstGeom prst="rect">
             <a:avLst/>
@@ -2442,20 +2442,20 @@
               <a:buNone/>
             </a:pPr>
             <a:r>
-              <a:rPr lang="en-US" sz="1300" i="1" dirty="0">
+              <a:rPr lang="en-US" sz="1250" i="1" dirty="0">
                 <a:solidFill>
                   <a:srgbClr val="595959"/>
                 </a:solidFill>
               </a:rPr>
-              <a:t>Each element moved into 20 closed backgrounds, against the same sequence shuffled. 50 Stable and 200 Dynamic donors, whole-peak width.</a:t>
-            </a:r>
-            <a:endParaRPr lang="en-US" sz="1300" dirty="0"/>
+              <a:t>Each element moved into 20 closed backgrounds and scored against the same sequence shuffled; one point per donor, whole-peak width. Black, median with a bootstrap 95% CI; Mann–Whitney.</a:t>
+            </a:r>
+            <a:endParaRPr lang="en-US" sz="1250" dirty="0"/>
           </a:p>
         </p:txBody>
       </p:sp>
       <p:pic>
         <p:nvPicPr>
-          <p:cNvPr id="4" name="Image 0" descr="/Users/z5162865/WongLab/AlphaGenome_Ap1/Analysis/slide_figures/s_fb_transplant.png">    </p:cNvPr>
+          <p:cNvPr id="4" name="Image 0" descr="/Users/z5162865/WongLab/AlphaGenome_Ap1/Analysis/slide_figures/r_fb_transplant.png">    </p:cNvPr>
           <p:cNvPicPr>
             <a:picLocks noChangeAspect="1"/>
           </p:cNvPicPr>
@@ -2469,8 +2469,8 @@
         </p:blipFill>
         <p:spPr>
           <a:xfrm>
-            <a:off x="2093800" y="1371600"/>
-            <a:ext cx="7973920" cy="3749040"/>
+            <a:off x="3343940" y="1335024"/>
+            <a:ext cx="5473641" cy="3566160"/>
           </a:xfrm>
           <a:prstGeom prst="rect">
             <a:avLst/>
@@ -2485,8 +2485,8 @@
         </p:nvSpPr>
         <p:spPr>
           <a:xfrm>
-            <a:off x="502920" y="5321808"/>
-            <a:ext cx="50292" cy="868680"/>
+            <a:off x="502920" y="5047488"/>
+            <a:ext cx="50292" cy="731520"/>
           </a:xfrm>
           <a:prstGeom prst="rect">
             <a:avLst/>
@@ -2510,8 +2510,8 @@
         </p:nvSpPr>
         <p:spPr>
           <a:xfrm>
-            <a:off x="749808" y="5321808"/>
-            <a:ext cx="10881360" cy="868680"/>
+            <a:off x="749808" y="5047488"/>
+            <a:ext cx="10881360" cy="731520"/>
           </a:xfrm>
           <a:prstGeom prst="rect">
             <a:avLst/>
@@ -2535,6 +2535,42 @@
               <a:t>Stable AP-1 elements carry enough sequence to build their own accessible site. Dynamic ones do not — they need the neighbourhood they came from. That is "context, not sequence autonomy", shown by moving the sequence.</a:t>
             </a:r>
             <a:endParaRPr lang="en-US" sz="1700" dirty="0"/>
+          </a:p>
+        </p:txBody>
+      </p:sp>
+      <p:sp>
+        <p:nvSpPr>
+          <p:cNvPr id="7" name="Text 4"/>
+          <p:cNvSpPr txBox="1"/>
+          <p:nvPr/>
+        </p:nvSpPr>
+        <p:spPr>
+          <a:xfrm>
+            <a:off x="749808" y="5852160"/>
+            <a:ext cx="10881360" cy="603504"/>
+          </a:xfrm>
+          <a:prstGeom prst="rect">
+            <a:avLst/>
+          </a:prstGeom>
+          <a:noFill/>
+          <a:ln/>
+        </p:spPr>
+        <p:txBody>
+          <a:bodyPr wrap="square" lIns="0" tIns="0" rIns="0" bIns="0" rtlCol="0" anchor="t"/>
+          <a:lstStyle/>
+          <a:p>
+            <a:pPr indent="0" marL="0">
+              <a:buNone/>
+            </a:pPr>
+            <a:r>
+              <a:rPr lang="en-US" sz="1300" dirty="0">
+                <a:solidFill>
+                  <a:srgbClr val="595959"/>
+                </a:solidFill>
+              </a:rPr>
+              <a:t>Stable donors also come from more accessible loci. Holding that constant (measured ATAC, 224 donors) a Stable element still gains 1.8× more than a Dynamic one, P = 0.005 — the direction holds, but about a third of the gap above is accessibility rather than sequence.</a:t>
+            </a:r>
+            <a:endParaRPr lang="en-US" sz="1300" dirty="0"/>
           </a:p>
         </p:txBody>
       </p:sp>
@@ -2654,8 +2690,8 @@
         </p:nvSpPr>
         <p:spPr>
           <a:xfrm>
-            <a:off x="502920" y="987552"/>
-            <a:ext cx="11155680" cy="292608"/>
+            <a:off x="502920" y="969264"/>
+            <a:ext cx="11155680" cy="310896"/>
           </a:xfrm>
           <a:prstGeom prst="rect">
             <a:avLst/>
@@ -2671,20 +2707,20 @@
               <a:buNone/>
             </a:pPr>
             <a:r>
-              <a:rPr lang="en-US" sz="1300" i="1" dirty="0">
+              <a:rPr lang="en-US" sz="1250" i="1" dirty="0">
                 <a:solidFill>
                   <a:srgbClr val="595959"/>
                 </a:solidFill>
               </a:rPr>
-              <a:t>Every element swapped into every other site's location: regression of the swapped site's accessibility on the donor element and on the recipient location.</a:t>
-            </a:r>
-            <a:endParaRPr lang="en-US" sz="1300" dirty="0"/>
+              <a:t>Every element swapped into every other site's location: the swapped site's accessibility regressed on the donor element and on the recipient location. 62,250 swaps; 95% CI from a cluster bootstrap over the 250 donors.</a:t>
+            </a:r>
+            <a:endParaRPr lang="en-US" sz="1250" dirty="0"/>
           </a:p>
         </p:txBody>
       </p:sp>
       <p:pic>
         <p:nvPicPr>
-          <p:cNvPr id="4" name="Image 0" descr="/Users/z5162865/WongLab/AlphaGenome_Ap1/Analysis/slide_figures/s_fb_scale.png">    </p:cNvPr>
+          <p:cNvPr id="4" name="Image 0" descr="/Users/z5162865/WongLab/AlphaGenome_Ap1/Analysis/slide_figures/r_fb_scale.png">    </p:cNvPr>
           <p:cNvPicPr>
             <a:picLocks noChangeAspect="1"/>
           </p:cNvPicPr>
@@ -2698,8 +2734,8 @@
         </p:blipFill>
         <p:spPr>
           <a:xfrm>
-            <a:off x="2869860" y="1371600"/>
-            <a:ext cx="6421801" cy="3749040"/>
+            <a:off x="2939902" y="1335024"/>
+            <a:ext cx="6281715" cy="3858768"/>
           </a:xfrm>
           <a:prstGeom prst="rect">
             <a:avLst/>
@@ -2714,7 +2750,7 @@
         </p:nvSpPr>
         <p:spPr>
           <a:xfrm>
-            <a:off x="502920" y="5321808"/>
+            <a:off x="502920" y="5303520"/>
             <a:ext cx="50292" cy="868680"/>
           </a:xfrm>
           <a:prstGeom prst="rect">
@@ -2739,7 +2775,7 @@
         </p:nvSpPr>
         <p:spPr>
           <a:xfrm>
-            <a:off x="749808" y="5321808"/>
+            <a:off x="749808" y="5303520"/>
             <a:ext cx="10881360" cy="868680"/>
           </a:xfrm>
           <a:prstGeom prst="rect">
@@ -2883,8 +2919,8 @@
         </p:nvSpPr>
         <p:spPr>
           <a:xfrm>
-            <a:off x="502920" y="987552"/>
-            <a:ext cx="11155680" cy="292608"/>
+            <a:off x="502920" y="969264"/>
+            <a:ext cx="11155680" cy="310896"/>
           </a:xfrm>
           <a:prstGeom prst="rect">
             <a:avLst/>
@@ -2900,20 +2936,20 @@
               <a:buNone/>
             </a:pPr>
             <a:r>
-              <a:rPr lang="en-US" sz="1300" i="1" dirty="0">
+              <a:rPr lang="en-US" sz="1250" i="1" dirty="0">
                 <a:solidFill>
                   <a:srgbClr val="595959"/>
                 </a:solidFill>
               </a:rPr>
-              <a:t>The site's own AP-1 motif and each partner motif shuffled separately inside the same window; partners net of a width- and distance-matched footprint-free control.</a:t>
-            </a:r>
-            <a:endParaRPr lang="en-US" sz="1300" dirty="0"/>
+              <a:t>The site's own AP-1 motif and each partner motif shuffled separately inside the same window; partners net of a width- and distance-matched footprint-free control. Violin, all 2,352 sites; point, median with a bootstrap 95% CI; Mann–Whitney.</a:t>
+            </a:r>
+            <a:endParaRPr lang="en-US" sz="1250" dirty="0"/>
           </a:p>
         </p:txBody>
       </p:sp>
       <p:pic>
         <p:nvPicPr>
-          <p:cNvPr id="4" name="Image 0" descr="/Users/z5162865/WongLab/AlphaGenome_Ap1/Analysis/slide_figures/s_fb_specificity.png">    </p:cNvPr>
+          <p:cNvPr id="4" name="Image 0" descr="/Users/z5162865/WongLab/AlphaGenome_Ap1/Analysis/slide_figures/r_fb_specificity.png">    </p:cNvPr>
           <p:cNvPicPr>
             <a:picLocks noChangeAspect="1"/>
           </p:cNvPicPr>
@@ -2927,8 +2963,8 @@
         </p:blipFill>
         <p:spPr>
           <a:xfrm>
-            <a:off x="3196777" y="1371600"/>
-            <a:ext cx="5767965" cy="3749040"/>
+            <a:off x="2479243" y="1335024"/>
+            <a:ext cx="7203034" cy="3858768"/>
           </a:xfrm>
           <a:prstGeom prst="rect">
             <a:avLst/>
@@ -2943,7 +2979,7 @@
         </p:nvSpPr>
         <p:spPr>
           <a:xfrm>
-            <a:off x="502920" y="5321808"/>
+            <a:off x="502920" y="5303520"/>
             <a:ext cx="50292" cy="868680"/>
           </a:xfrm>
           <a:prstGeom prst="rect">
@@ -2968,7 +3004,7 @@
         </p:nvSpPr>
         <p:spPr>
           <a:xfrm>
-            <a:off x="749808" y="5321808"/>
+            <a:off x="749808" y="5303520"/>
             <a:ext cx="10881360" cy="868680"/>
           </a:xfrm>
           <a:prstGeom prst="rect">
@@ -3112,8 +3148,8 @@
         </p:nvSpPr>
         <p:spPr>
           <a:xfrm>
-            <a:off x="502920" y="987552"/>
-            <a:ext cx="11155680" cy="292608"/>
+            <a:off x="502920" y="969264"/>
+            <a:ext cx="11155680" cy="310896"/>
           </a:xfrm>
           <a:prstGeom prst="rect">
             <a:avLst/>
@@ -3129,20 +3165,20 @@
               <a:buNone/>
             </a:pPr>
             <a:r>
-              <a:rPr lang="en-US" sz="1300" i="1" dirty="0">
+              <a:rPr lang="en-US" sz="1250" i="1" dirty="0">
                 <a:solidFill>
                   <a:srgbClr val="595959"/>
                 </a:solidFill>
               </a:rPr>
-              <a:t>Per site: |own AP-1| / (|own AP-1| + |partner motifs|). Both terms are AlphaGenome shuffle effects measured inside the same window, so accessibility cannot drive the comparison.</a:t>
-            </a:r>
-            <a:endParaRPr lang="en-US" sz="1300" dirty="0"/>
+              <a:t>Per site: |own AP-1| / (|own AP-1| + |partner motifs|). Both terms are AlphaGenome shuffle effects measured inside the same window, so accessibility cannot drive the comparison. Violin with box (median, IQR); Mann–Whitney.</a:t>
+            </a:r>
+            <a:endParaRPr lang="en-US" sz="1250" dirty="0"/>
           </a:p>
         </p:txBody>
       </p:sp>
       <p:pic>
         <p:nvPicPr>
-          <p:cNvPr id="4" name="Image 0" descr="/Users/z5162865/WongLab/AlphaGenome_Ap1/Analysis/slide_figures/s_fb_share.png">    </p:cNvPr>
+          <p:cNvPr id="4" name="Image 0" descr="/Users/z5162865/WongLab/AlphaGenome_Ap1/Analysis/slide_figures/r_fb_share.png">    </p:cNvPr>
           <p:cNvPicPr>
             <a:picLocks noChangeAspect="1"/>
           </p:cNvPicPr>
@@ -3156,8 +3192,8 @@
         </p:blipFill>
         <p:spPr>
           <a:xfrm>
-            <a:off x="2987316" y="1371600"/>
-            <a:ext cx="6186887" cy="3749040"/>
+            <a:off x="3250997" y="1335024"/>
+            <a:ext cx="5659526" cy="3858768"/>
           </a:xfrm>
           <a:prstGeom prst="rect">
             <a:avLst/>
@@ -3172,7 +3208,7 @@
         </p:nvSpPr>
         <p:spPr>
           <a:xfrm>
-            <a:off x="502920" y="5321808"/>
+            <a:off x="502920" y="5303520"/>
             <a:ext cx="50292" cy="868680"/>
           </a:xfrm>
           <a:prstGeom prst="rect">
@@ -3197,7 +3233,7 @@
         </p:nvSpPr>
         <p:spPr>
           <a:xfrm>
-            <a:off x="749808" y="5321808"/>
+            <a:off x="749808" y="5303520"/>
             <a:ext cx="10881360" cy="868680"/>
           </a:xfrm>
           <a:prstGeom prst="rect">

</xml_diff>

<commit_message>
Slide 9's annotation becomes PowerPoint text; slide 7 says what it means
The legend, the header and the FDR row are no longer drawn into the
specificity PNG. fb_slide_figures.R measures the ggplot panel and writes
r_fb_specificity_overlay.json; the deck places each label as a real text
box at the data coordinate ggplot would have used. Move, reword or delete
any of them on the slide without regenerating anything.

That also fixes a defect: the header sat at x = 0.22 on a panel whose
range starts at 0.735, so ggplot was clipping its first word.

Slide 7 was being read as two opposed weights. Both are positive; the
axis now says so, and a reading line under the takeaway spells out what
a transplant of a strong element into a weak place actually does.

Co-Authored-By: Claude Opus 5 <noreply@anthropic.com>
</commit_message>
<xml_diff>
--- a/Analysis/AP1_fibroblast_lab_meeting.pptx
+++ b/Analysis/AP1_fibroblast_lab_meeting.pptx
@@ -19587,7 +19587,7 @@
                   <a:srgbClr val="595959"/>
                 </a:solidFill>
               </a:rPr>
-              <a:t>Every element swapped into every other site's location: the swapped site's accessibility regressed on the donor element and on the recipient location. The two weights are drawn pulling against each other from a common zero. 62,250 swaps; 95% CI from a cluster bootstrap over the 250 donors.</a:t>
+              <a:t>Every element written into every other site's location; the accessibility that results regressed on the donor element's own level and on the recipient location's. Both weights are positive, drawn apart only so the pair can be compared. 62,250 swaps; 95% CI from a cluster bootstrap over 250 donors.</a:t>
             </a:r>
             <a:endParaRPr lang="en-US" sz="1250" dirty="0"/>
           </a:p>
@@ -19609,8 +19609,8 @@
         </p:blipFill>
         <p:spPr>
           <a:xfrm>
-            <a:off x="1064362" y="1335024"/>
-            <a:ext cx="10032797" cy="3858768"/>
+            <a:off x="1444752" y="1335024"/>
+            <a:ext cx="9272016" cy="3566160"/>
           </a:xfrm>
           <a:prstGeom prst="rect">
             <a:avLst/>
@@ -19625,8 +19625,8 @@
         </p:nvSpPr>
         <p:spPr>
           <a:xfrm>
-            <a:off x="502920" y="5303520"/>
-            <a:ext cx="50292" cy="868680"/>
+            <a:off x="502920" y="5047488"/>
+            <a:ext cx="50292" cy="731520"/>
           </a:xfrm>
           <a:prstGeom prst="rect">
             <a:avLst/>
@@ -19650,8 +19650,8 @@
         </p:nvSpPr>
         <p:spPr>
           <a:xfrm>
-            <a:off x="749808" y="5303520"/>
-            <a:ext cx="10881360" cy="868680"/>
+            <a:off x="749808" y="5047488"/>
+            <a:ext cx="10881360" cy="731520"/>
           </a:xfrm>
           <a:prstGeom prst="rect">
             <a:avLst/>
@@ -19675,6 +19675,42 @@
               <a:t>At 170 bp an element mostly takes on the level of wherever you put it; at full peak width it imposes its own. The information that opens chromatin is spread over the whole peak — which is why a 170 bp assay cannot see it.</a:t>
             </a:r>
             <a:endParaRPr lang="en-US" sz="1700" dirty="0"/>
+          </a:p>
+        </p:txBody>
+      </p:sp>
+      <p:sp>
+        <p:nvSpPr>
+          <p:cNvPr id="7" name="Text 4"/>
+          <p:cNvSpPr txBox="1"/>
+          <p:nvPr/>
+        </p:nvSpPr>
+        <p:spPr>
+          <a:xfrm>
+            <a:off x="749808" y="5852160"/>
+            <a:ext cx="10881360" cy="603504"/>
+          </a:xfrm>
+          <a:prstGeom prst="rect">
+            <a:avLst/>
+          </a:prstGeom>
+          <a:noFill/>
+          <a:ln/>
+        </p:spPr>
+        <p:txBody>
+          <a:bodyPr wrap="square" lIns="0" tIns="0" rIns="0" bIns="0" rtlCol="0" anchor="t"/>
+          <a:lstStyle/>
+          <a:p>
+            <a:pPr indent="0" marL="0">
+              <a:buNone/>
+            </a:pPr>
+            <a:r>
+              <a:rPr lang="en-US" sz="1300" dirty="0">
+                <a:solidFill>
+                  <a:srgbClr val="595959"/>
+                </a:solidFill>
+              </a:rPr>
+              <a:t>Read it as a transplant: take a strong element, put it somewhere weak. At 170 bp it comes out weak — the location carries most of the weight (0.61 against 0.24). At full peak width it stays strong — the element now carries most of it (0.71 against 0.20). Nothing about the element changed, only how much of it we moved. P tests the two weights against each other.</a:t>
+            </a:r>
+            <a:endParaRPr lang="en-US" sz="1300" dirty="0"/>
           </a:p>
         </p:txBody>
       </p:sp>
@@ -22748,6 +22784,368 @@
         </p:nvSpPr>
         <p:spPr>
           <a:xfrm>
+            <a:off x="6283142" y="1544898"/>
+            <a:ext cx="137160" cy="137160"/>
+          </a:xfrm>
+          <a:prstGeom prst="rect">
+            <a:avLst/>
+          </a:prstGeom>
+          <a:solidFill>
+            <a:srgbClr val="D6D6D6"/>
+          </a:solidFill>
+          <a:ln w="11430">
+            <a:solidFill>
+              <a:srgbClr val="111111"/>
+            </a:solidFill>
+            <a:prstDash val="solid"/>
+          </a:ln>
+        </p:spPr>
+      </p:sp>
+      <p:sp>
+        <p:nvSpPr>
+          <p:cNvPr id="6" name="Shape 3"/>
+          <p:cNvSpPr/>
+          <p:nvPr/>
+        </p:nvSpPr>
+        <p:spPr>
+          <a:xfrm>
+            <a:off x="6283142" y="1743113"/>
+            <a:ext cx="137160" cy="137160"/>
+          </a:xfrm>
+          <a:prstGeom prst="rect">
+            <a:avLst/>
+          </a:prstGeom>
+          <a:solidFill>
+            <a:srgbClr val="FFFFFF"/>
+          </a:solidFill>
+          <a:ln w="11430">
+            <a:solidFill>
+              <a:srgbClr val="111111"/>
+            </a:solidFill>
+            <a:prstDash val="solid"/>
+          </a:ln>
+        </p:spPr>
+      </p:sp>
+      <p:sp>
+        <p:nvSpPr>
+          <p:cNvPr id="7" name="Text 4"/>
+          <p:cNvSpPr txBox="1"/>
+          <p:nvPr/>
+        </p:nvSpPr>
+        <p:spPr>
+          <a:xfrm>
+            <a:off x="2010934" y="1613535"/>
+            <a:ext cx="5277917" cy="237744"/>
+          </a:xfrm>
+          <a:prstGeom prst="rect">
+            <a:avLst/>
+          </a:prstGeom>
+          <a:noFill/>
+          <a:ln/>
+        </p:spPr>
+        <p:txBody>
+          <a:bodyPr wrap="none" lIns="0" tIns="0" rIns="0" bIns="0" rtlCol="0" anchor="ctr"/>
+          <a:lstStyle/>
+          <a:p>
+            <a:pPr algn="l" indent="0" marL="0">
+              <a:buNone/>
+            </a:pPr>
+            <a:r>
+              <a:rPr lang="en-US" sz="1233" dirty="0">
+                <a:solidFill>
+                  <a:srgbClr val="4D4D4D"/>
+                </a:solidFill>
+                <a:latin typeface="Arial" pitchFamily="34" charset="0"/>
+                <a:ea typeface="Arial" pitchFamily="34" charset="-122"/>
+                <a:cs typeface="Arial" pitchFamily="34" charset="-120"/>
+              </a:rPr>
+              <a:t>vs Stable, at the site's own AP-1 motif (BH across the four)</a:t>
+            </a:r>
+            <a:endParaRPr lang="en-US" sz="1233" dirty="0"/>
+          </a:p>
+        </p:txBody>
+      </p:sp>
+      <p:sp>
+        <p:nvSpPr>
+          <p:cNvPr id="8" name="Text 5"/>
+          <p:cNvSpPr txBox="1"/>
+          <p:nvPr/>
+        </p:nvSpPr>
+        <p:spPr>
+          <a:xfrm>
+            <a:off x="1654682" y="2009965"/>
+            <a:ext cx="914400" cy="237744"/>
+          </a:xfrm>
+          <a:prstGeom prst="rect">
+            <a:avLst/>
+          </a:prstGeom>
+          <a:noFill/>
+          <a:ln/>
+        </p:spPr>
+        <p:txBody>
+          <a:bodyPr wrap="none" lIns="0" tIns="0" rIns="0" bIns="0" rtlCol="0" anchor="ctr"/>
+          <a:lstStyle/>
+          <a:p>
+            <a:pPr algn="ctr" indent="0" marL="0">
+              <a:buNone/>
+            </a:pPr>
+            <a:r>
+              <a:rPr lang="en-US" sz="1233" dirty="0">
+                <a:solidFill>
+                  <a:srgbClr val="4D4D4D"/>
+                </a:solidFill>
+                <a:latin typeface="Arial" pitchFamily="34" charset="0"/>
+                <a:ea typeface="Arial" pitchFamily="34" charset="-122"/>
+                <a:cs typeface="Arial" pitchFamily="34" charset="-120"/>
+              </a:rPr>
+              <a:t>reference</a:t>
+            </a:r>
+            <a:endParaRPr lang="en-US" sz="1233" dirty="0"/>
+          </a:p>
+        </p:txBody>
+      </p:sp>
+      <p:sp>
+        <p:nvSpPr>
+          <p:cNvPr id="9" name="Text 6"/>
+          <p:cNvSpPr txBox="1"/>
+          <p:nvPr/>
+        </p:nvSpPr>
+        <p:spPr>
+          <a:xfrm>
+            <a:off x="3673654" y="2009965"/>
+            <a:ext cx="914400" cy="237744"/>
+          </a:xfrm>
+          <a:prstGeom prst="rect">
+            <a:avLst/>
+          </a:prstGeom>
+          <a:noFill/>
+          <a:ln/>
+        </p:spPr>
+        <p:txBody>
+          <a:bodyPr wrap="none" lIns="0" tIns="0" rIns="0" bIns="0" rtlCol="0" anchor="ctr"/>
+          <a:lstStyle/>
+          <a:p>
+            <a:pPr algn="ctr" indent="0" marL="0">
+              <a:buNone/>
+            </a:pPr>
+            <a:r>
+              <a:rPr lang="en-US" sz="1233" dirty="0">
+                <a:solidFill>
+                  <a:srgbClr val="4D4D4D"/>
+                </a:solidFill>
+                <a:latin typeface="Arial" pitchFamily="34" charset="0"/>
+                <a:ea typeface="Arial" pitchFamily="34" charset="-122"/>
+                <a:cs typeface="Arial" pitchFamily="34" charset="-120"/>
+              </a:rPr>
+              <a:t>FDR = 0.93</a:t>
+            </a:r>
+            <a:endParaRPr lang="en-US" sz="1233" dirty="0"/>
+          </a:p>
+        </p:txBody>
+      </p:sp>
+      <p:sp>
+        <p:nvSpPr>
+          <p:cNvPr id="10" name="Text 7"/>
+          <p:cNvSpPr txBox="1"/>
+          <p:nvPr/>
+        </p:nvSpPr>
+        <p:spPr>
+          <a:xfrm>
+            <a:off x="5446103" y="2009965"/>
+            <a:ext cx="1407444" cy="237744"/>
+          </a:xfrm>
+          <a:prstGeom prst="rect">
+            <a:avLst/>
+          </a:prstGeom>
+          <a:noFill/>
+          <a:ln/>
+        </p:spPr>
+        <p:txBody>
+          <a:bodyPr wrap="none" lIns="0" tIns="0" rIns="0" bIns="0" rtlCol="0" anchor="ctr"/>
+          <a:lstStyle/>
+          <a:p>
+            <a:pPr algn="ctr" indent="0" marL="0">
+              <a:buNone/>
+            </a:pPr>
+            <a:r>
+              <a:rPr lang="en-US" sz="1233" dirty="0">
+                <a:solidFill>
+                  <a:srgbClr val="4D4D4D"/>
+                </a:solidFill>
+                <a:latin typeface="Arial" pitchFamily="34" charset="0"/>
+                <a:ea typeface="Arial" pitchFamily="34" charset="-122"/>
+                <a:cs typeface="Arial" pitchFamily="34" charset="-120"/>
+              </a:rPr>
+              <a:t>FDR = 9.1 × 10⁻⁵</a:t>
+            </a:r>
+            <a:endParaRPr lang="en-US" sz="1233" dirty="0"/>
+          </a:p>
+        </p:txBody>
+      </p:sp>
+      <p:sp>
+        <p:nvSpPr>
+          <p:cNvPr id="11" name="Text 8"/>
+          <p:cNvSpPr txBox="1"/>
+          <p:nvPr/>
+        </p:nvSpPr>
+        <p:spPr>
+          <a:xfrm>
+            <a:off x="7711596" y="2009965"/>
+            <a:ext cx="914400" cy="237744"/>
+          </a:xfrm>
+          <a:prstGeom prst="rect">
+            <a:avLst/>
+          </a:prstGeom>
+          <a:noFill/>
+          <a:ln/>
+        </p:spPr>
+        <p:txBody>
+          <a:bodyPr wrap="none" lIns="0" tIns="0" rIns="0" bIns="0" rtlCol="0" anchor="ctr"/>
+          <a:lstStyle/>
+          <a:p>
+            <a:pPr algn="ctr" indent="0" marL="0">
+              <a:buNone/>
+            </a:pPr>
+            <a:r>
+              <a:rPr lang="en-US" sz="1233" dirty="0">
+                <a:solidFill>
+                  <a:srgbClr val="4D4D4D"/>
+                </a:solidFill>
+                <a:latin typeface="Arial" pitchFamily="34" charset="0"/>
+                <a:ea typeface="Arial" pitchFamily="34" charset="-122"/>
+                <a:cs typeface="Arial" pitchFamily="34" charset="-120"/>
+              </a:rPr>
+              <a:t>FDR = 0.49</a:t>
+            </a:r>
+            <a:endParaRPr lang="en-US" sz="1233" dirty="0"/>
+          </a:p>
+        </p:txBody>
+      </p:sp>
+      <p:sp>
+        <p:nvSpPr>
+          <p:cNvPr id="12" name="Text 9"/>
+          <p:cNvSpPr txBox="1"/>
+          <p:nvPr/>
+        </p:nvSpPr>
+        <p:spPr>
+          <a:xfrm>
+            <a:off x="9703958" y="2009965"/>
+            <a:ext cx="967618" cy="237744"/>
+          </a:xfrm>
+          <a:prstGeom prst="rect">
+            <a:avLst/>
+          </a:prstGeom>
+          <a:noFill/>
+          <a:ln/>
+        </p:spPr>
+        <p:txBody>
+          <a:bodyPr wrap="none" lIns="0" tIns="0" rIns="0" bIns="0" rtlCol="0" anchor="ctr"/>
+          <a:lstStyle/>
+          <a:p>
+            <a:pPr algn="ctr" indent="0" marL="0">
+              <a:buNone/>
+            </a:pPr>
+            <a:r>
+              <a:rPr lang="en-US" sz="1233" dirty="0">
+                <a:solidFill>
+                  <a:srgbClr val="4D4D4D"/>
+                </a:solidFill>
+                <a:latin typeface="Arial" pitchFamily="34" charset="0"/>
+                <a:ea typeface="Arial" pitchFamily="34" charset="-122"/>
+                <a:cs typeface="Arial" pitchFamily="34" charset="-120"/>
+              </a:rPr>
+              <a:t>FDR = 0.043</a:t>
+            </a:r>
+            <a:endParaRPr lang="en-US" sz="1233" dirty="0"/>
+          </a:p>
+        </p:txBody>
+      </p:sp>
+      <p:sp>
+        <p:nvSpPr>
+          <p:cNvPr id="13" name="Text 10"/>
+          <p:cNvSpPr txBox="1"/>
+          <p:nvPr/>
+        </p:nvSpPr>
+        <p:spPr>
+          <a:xfrm>
+            <a:off x="6513240" y="1494606"/>
+            <a:ext cx="1649349" cy="237744"/>
+          </a:xfrm>
+          <a:prstGeom prst="rect">
+            <a:avLst/>
+          </a:prstGeom>
+          <a:noFill/>
+          <a:ln/>
+        </p:spPr>
+        <p:txBody>
+          <a:bodyPr wrap="none" lIns="0" tIns="0" rIns="0" bIns="0" rtlCol="0" anchor="ctr"/>
+          <a:lstStyle/>
+          <a:p>
+            <a:pPr algn="l" indent="0" marL="0">
+              <a:buNone/>
+            </a:pPr>
+            <a:r>
+              <a:rPr lang="en-US" sz="1285" dirty="0">
+                <a:solidFill>
+                  <a:srgbClr val="111111"/>
+                </a:solidFill>
+                <a:latin typeface="Arial" pitchFamily="34" charset="0"/>
+                <a:ea typeface="Arial" pitchFamily="34" charset="-122"/>
+                <a:cs typeface="Arial" pitchFamily="34" charset="-120"/>
+              </a:rPr>
+              <a:t>its own AP-1 motif</a:t>
+            </a:r>
+            <a:endParaRPr lang="en-US" sz="1285" dirty="0"/>
+          </a:p>
+        </p:txBody>
+      </p:sp>
+      <p:sp>
+        <p:nvSpPr>
+          <p:cNvPr id="14" name="Text 11"/>
+          <p:cNvSpPr txBox="1"/>
+          <p:nvPr/>
+        </p:nvSpPr>
+        <p:spPr>
+          <a:xfrm>
+            <a:off x="6513240" y="1692821"/>
+            <a:ext cx="4031742" cy="237744"/>
+          </a:xfrm>
+          <a:prstGeom prst="rect">
+            <a:avLst/>
+          </a:prstGeom>
+          <a:noFill/>
+          <a:ln/>
+        </p:spPr>
+        <p:txBody>
+          <a:bodyPr wrap="none" lIns="0" tIns="0" rIns="0" bIns="0" rtlCol="0" anchor="ctr"/>
+          <a:lstStyle/>
+          <a:p>
+            <a:pPr algn="l" indent="0" marL="0">
+              <a:buNone/>
+            </a:pPr>
+            <a:r>
+              <a:rPr lang="en-US" sz="1285" dirty="0">
+                <a:solidFill>
+                  <a:srgbClr val="111111"/>
+                </a:solidFill>
+                <a:latin typeface="Arial" pitchFamily="34" charset="0"/>
+                <a:ea typeface="Arial" pitchFamily="34" charset="-122"/>
+                <a:cs typeface="Arial" pitchFamily="34" charset="-120"/>
+              </a:rPr>
+              <a:t>its partner motifs, net of a matched control</a:t>
+            </a:r>
+            <a:endParaRPr lang="en-US" sz="1285" dirty="0"/>
+          </a:p>
+        </p:txBody>
+      </p:sp>
+      <p:sp>
+        <p:nvSpPr>
+          <p:cNvPr id="15" name="Shape 12"/>
+          <p:cNvSpPr/>
+          <p:nvPr/>
+        </p:nvSpPr>
+        <p:spPr>
+          <a:xfrm>
             <a:off x="502920" y="5303520"/>
             <a:ext cx="50292" cy="868680"/>
           </a:xfrm>
@@ -22767,7 +23165,7 @@
       </p:sp>
       <p:sp>
         <p:nvSpPr>
-          <p:cNvPr id="6" name="Text 3"/>
+          <p:cNvPr id="16" name="Text 13"/>
           <p:cNvSpPr txBox="1"/>
           <p:nvPr/>
         </p:nvSpPr>

</xml_diff>

<commit_message>
Slide 7 becomes a class result, because there is one
Fitted per donor class, a Stable element carries 84% of its own level
into a new location and every Dynamic class carries less (73-79%), three
of four at FDR < 0.05. That is the same autonomy conclusion as the
transplant, reached without a closed background anywhere in the design.

The slide used to show one regression pooled over all 62,250 swaps,
which said something about assay width and nothing about class. The
width contrast moves to the caveat line, where it is still worth having:
at 170 bp almost nothing transfers for any Dynamic class.

Co-Authored-By: Claude Opus 5 <noreply@anthropic.com>
</commit_message>
<xml_diff>
--- a/Analysis/AP1_fibroblast_lab_meeting.pptx
+++ b/Analysis/AP1_fibroblast_lab_meeting.pptx
@@ -1893,7 +1893,13 @@
           <a:p>
             <a:r>
               <a:rPr lang="en-US" dirty="0"/>
-              <a:t>62,250 swaps. 170 bp: beta(element) 0.24 vs beta(location) 0.61, R2 = 0.20. Whole peak: 0.71 vs 0.20, R2 = 0.46. Transfer fraction 0.29 at 170 bp, 0.83 at peak.
+              <a:t>THE CLASS RESULT, whole peak, element's share of its own level ('carried'), BH across the four:
+  Stable 84.1% [80.9-87.0] (reference) · Age Up 77.8% [73.4-81.4] FDR 0.020 · Age Down 78.6% [72.6-83.2] FDR 0.063 · Exercise Up 76.0% [69.7-80.5] FDR 0.010 · Exercise Down 72.7% [62.3-79.2] FDR 0.004
+Underlying weights, element vs location: Stable 0.79/0.15, Age Up 0.72/0.21, Age Down 0.67/0.18, Exercise Up 0.69/0.22, Exercise Down 0.60/0.23. R2 0.65 for Stable, 0.27-0.50 for the Dynamic classes.
+Age Down at FDR 0.063 is the one that does not clear the line. Say 'three of four' rather than 'all four'; the direction is the same in every class and the ordering is monotone, but one of them is not significant.
+Every interval resamples DONORS, not swaps: each donor appears in ~250 rows, so a row-level standard error would be far too small and all five classes would look certain.
+170 bp, for contrast: Stable carries 39.8% [23.7-51.0]; Age Up 11.9%, Age Down 11.0%, Exercise Up -0.9%, Exercise Down 33.6%, three of four below Stable at FDR &lt; 0.05. The Dynamic intervals there cross zero, so treat the 170 bp row as 'almost nothing transfers' rather than as a clean ranking.
+Pooled over all classes, which is what this slide used to show: 170 bp 0.24 vs 0.61, whole peak 0.71 vs 0.20.
 Link to the MPRA, if asked: the MPRA library is 170 bp, and its class difference there is tiny (flank shuffle 0.128 vs 0.016 log2, d = 0.14). Both assays agree that 170 bp is a poor window for this question. They are NOT the same measurement - the MPRA is episomal activity, this is chromatin accessibility in genomic context.
 AVOID on a slide: our in-situ 170 bp shuffle has Stable sites losing more (-2.51 vs -1.96, p = 4e-40), which is the opposite direction to the MPRA flank result. Different assay, but it reads as a contradiction. Keep it off unless someone asks.</a:t>
             </a:r>
@@ -19551,7 +19557,7 @@
                   <a:schemeClr val="tx1"/>
                 </a:solidFill>
               </a:rPr>
-              <a:t>The element's identity lives at peak scale, not in 170 bp</a:t>
+              <a:t>A Stable element carries more of itself into a new location</a:t>
             </a:r>
             <a:endParaRPr lang="en-US" sz="2800" dirty="0"/>
           </a:p>
@@ -19587,7 +19593,7 @@
                   <a:srgbClr val="595959"/>
                 </a:solidFill>
               </a:rPr>
-              <a:t>Every element written into every other site's location; the accessibility that results regressed on the donor element's own level and on the recipient location's. Both weights are positive, drawn apart only so the pair can be compared. 62,250 swaps; 95% CI from a cluster bootstrap over 250 donors.</a:t>
+              <a:t>Every element written into every other site's location, at whole-peak width; the resulting accessibility regressed on the donor element's own level and the recipient location's, within each class. 'Carried' is the element's share of the two. Cluster bootstrap over 50 donors per class, BH across four.</a:t>
             </a:r>
             <a:endParaRPr lang="en-US" sz="1250" dirty="0"/>
           </a:p>
@@ -19609,8 +19615,8 @@
         </p:blipFill>
         <p:spPr>
           <a:xfrm>
-            <a:off x="1444752" y="1335024"/>
-            <a:ext cx="9272016" cy="3566160"/>
+            <a:off x="1602327" y="1335024"/>
+            <a:ext cx="8956867" cy="3566160"/>
           </a:xfrm>
           <a:prstGeom prst="rect">
             <a:avLst/>
@@ -19672,7 +19678,7 @@
                   <a:srgbClr val="111111"/>
                 </a:solidFill>
               </a:rPr>
-              <a:t>At 170 bp an element mostly takes on the level of wherever you put it; at full peak width it imposes its own. The information that opens chromatin is spread over the whole peak — which is why a 170 bp assay cannot see it.</a:t>
+              <a:t>Move an element somewhere else and a Stable one brings 84% of its own level with it; every Dynamic class brings less, 73–79%, and three of the four differ from Stable. A Dynamic element is more a product of where it sits — the same conclusion the transplant reached, from a design with no closed background in it.</a:t>
             </a:r>
             <a:endParaRPr lang="en-US" sz="1700" dirty="0"/>
           </a:p>
@@ -19708,7 +19714,7 @@
                   <a:srgbClr val="595959"/>
                 </a:solidFill>
               </a:rPr>
-              <a:t>Read it as a transplant: take a strong element, put it somewhere weak. At 170 bp it comes out weak — the location carries most of the weight (0.61 against 0.24). At full peak width it stays strong — the element now carries most of it (0.71 against 0.20). Nothing about the element changed, only how much of it we moved. P tests the two weights against each other.</a:t>
+              <a:t>Width matters as much as class: at the 170 bp MPRA window a Stable element carries only 40% and the Dynamic classes essentially nothing (−1% to 34%, intervals crossing zero). The information that opens chromatin is spread over the whole peak, which is why a 170 bp assay struggles to see any of this.</a:t>
             </a:r>
             <a:endParaRPr lang="en-US" sz="1300" dirty="0"/>
           </a:p>

</xml_diff>

<commit_message>
One slide saying how every result handles the accessibility gap
Stable sites are about twice as accessible as Dynamic ones, so this is
the first question each result gets. Five categories: immune by design
(within-site contrasts), accessibility as a regressor (the swap),
matched and survived (density), survives only as a covariate adjustment
(transplant), and checked but did not survive (top tile).

Corrects what the transplant slide implied: its 1:1 matched test is not
significant (47 pairs, P = 0.13). The covariate-adjusted gap is the one
to quote.

Co-Authored-By: Claude Opus 5 <noreply@anthropic.com>
</commit_message>
<xml_diff>
--- a/Analysis/AP1_fibroblast_lab_meeting.pptx
+++ b/Analysis/AP1_fibroblast_lab_meeting.pptx
@@ -23,9 +23,10 @@
     <p:sldId id="271" r:id="rId17"/>
     <p:sldId id="272" r:id="rId18"/>
     <p:sldId id="273" r:id="rId19"/>
+    <p:sldId id="274" r:id="rId20"/>
   </p:sldIdLst>
   <p:notesMasterIdLst>
-    <p:notesMasterId r:id="rId20"/>
+    <p:notesMasterId r:id="rId21"/>
   </p:notesMasterIdLst>
   <p:sldSz cx="12192000" cy="6858000"/>
   <p:notesSz cx="6858000" cy="12192000"/>
@@ -1260,8 +1261,11 @@
           <a:p>
             <a:r>
               <a:rPr lang="en-US" dirty="0"/>
-              <a:t>From the fibroblast titration, 2,359 sites, 860 accessibility-matched pairs (caliper 0.1 log10). This slide is the argument for why the matched analysis is worth doing - two of the five largest raw class differences in the titration were entirely explained by the accessibility gap.
-Age Down is the outlier again, consistently with the other arms: one base of the core changed -0.62 vs Stable -0.83; motif gone -0.72 vs -1.07.</a:t>
+              <a:t>Keep this one in the back pocket; it is the first question any of these results gets.
+The size of the confound: Stable sites are about twice as accessible as Dynamic ones (measured native 32.2 vs 18.0 in the swap donors; predicted 10.5 vs 8.5 across the scan sites).
+Two different things are matched on in different places, and it is worth being straight about it: the transplant matches on MEASURED native accessibility, the density and top-tile analyses on PREDICTED. Matching on predicted is the more conservative choice for a prediction-based readout, because it removes the thing the model itself would key on.
+Not matched, and said so on the slides: the three alternative density readings. The pooled Stable-vs-Dynamic contrast they re-draw is the one that survives matching; the five-class split has not been matched, because Exercise Down has 115 sites and would not support it.
+Why 1:1 matching keeps coming out underpowered: a caliper of 0.1 log10 on populations that differ roughly two-fold throws most of the Dynamic sites away. Where the n allows it (860 pairs in the scan) it is the better test; where it does not (47 donor pairs in the transplant) the covariate adjustment uses every site and is the one to quote.</a:t>
             </a:r>
             <a:endParaRPr lang="en-US" dirty="0"/>
           </a:p>
@@ -1349,8 +1353,8 @@
           <a:p>
             <a:r>
               <a:rPr lang="en-US" dirty="0"/>
-              <a:t>If the flank question comes up: the MPRA destroys the flanks of a 170 bp fragment on a plasmid and reads transcription; we move an intact ~0.8 kb element into closed chromatin and read accessibility. There is no chromatin to open in the MPRA. The honest shared conclusion is that neither assay finds much class information in 170 bp.
-Everything here is predicted accessibility from a model fine-tuned on our own fibroblast ATAC, not a measurement, and not the MPRA-trained probe used in the manuscript.</a:t>
+              <a:t>From the fibroblast titration, 2,359 sites, 860 accessibility-matched pairs (caliper 0.1 log10). This slide is the argument for why the matched analysis is worth doing - two of the five largest raw class differences in the titration were entirely explained by the accessibility gap.
+Age Down is the outlier again, consistently with the other arms: one base of the core changed -0.62 vs Stable -0.83; motif gone -0.72 vs -1.07.</a:t>
             </a:r>
             <a:endParaRPr lang="en-US" dirty="0"/>
           </a:p>
@@ -1374,6 +1378,95 @@
             <a:fld id="{F7021451-1387-4CA6-816F-3879F97B5CBC}" type="slidenum">
               <a:rPr lang="en-US"/>
               <a:t>18</a:t>
+            </a:fld>
+            <a:endParaRPr lang="en-US"/>
+          </a:p>
+        </p:txBody>
+      </p:sp>
+    </p:spTree>
+    <p:extLst>
+      <p:ext uri="{BB962C8B-B14F-4D97-AF65-F5344CB8AC3E}">
+        <p14:creationId xmlns:p14="http://schemas.microsoft.com/office/powerpoint/2010/main" val="1024086991"/>
+      </p:ext>
+    </p:extLst>
+  </p:cSld>
+  <p:clrMapOvr>
+    <a:masterClrMapping/>
+  </p:clrMapOvr>
+</p:notes>
+</file>
+
+<file path=ppt/notesSlides/notesSlide19.xml><?xml version="1.0" encoding="utf-8"?>
+<p:notes xmlns:a="http://schemas.openxmlformats.org/drawingml/2006/main" xmlns:r="http://schemas.openxmlformats.org/officeDocument/2006/relationships" xmlns:p="http://schemas.openxmlformats.org/presentationml/2006/main">
+  <p:cSld>
+    <p:spTree>
+      <p:nvGrpSpPr>
+        <p:cNvPr id="1" name=""/>
+        <p:cNvGrpSpPr/>
+        <p:nvPr/>
+      </p:nvGrpSpPr>
+      <p:grpSpPr>
+        <a:xfrm>
+          <a:off x="0" y="0"/>
+          <a:ext cx="0" cy="0"/>
+          <a:chOff x="0" y="0"/>
+          <a:chExt cx="0" cy="0"/>
+        </a:xfrm>
+      </p:grpSpPr>
+      <p:sp>
+        <p:nvSpPr>
+          <p:cNvPr id="2" name="Slide Image Placeholder 1"/>
+          <p:cNvSpPr>
+            <a:spLocks noGrp="1" noRot="1" noChangeAspect="1"/>
+          </p:cNvSpPr>
+          <p:nvPr>
+            <p:ph type="sldImg"/>
+          </p:nvPr>
+        </p:nvSpPr>
+        <p:spPr/>
+      </p:sp>
+      <p:sp>
+        <p:nvSpPr>
+          <p:cNvPr id="3" name="Notes Placeholder 2"/>
+          <p:cNvSpPr>
+            <a:spLocks noGrp="1"/>
+          </p:cNvSpPr>
+          <p:nvPr>
+            <p:ph type="body" idx="1"/>
+          </p:nvPr>
+        </p:nvSpPr>
+        <p:spPr/>
+        <p:txBody>
+          <a:bodyPr/>
+          <a:lstStyle/>
+          <a:p>
+            <a:r>
+              <a:rPr lang="en-US" dirty="0"/>
+              <a:t>If the flank question comes up: the MPRA destroys the flanks of a 170 bp fragment on a plasmid and reads transcription; we move an intact ~0.8 kb element into closed chromatin and read accessibility. There is no chromatin to open in the MPRA. The honest shared conclusion is that neither assay finds much class information in 170 bp.
+Everything here is predicted accessibility from a model fine-tuned on our own fibroblast ATAC, not a measurement, and not the MPRA-trained probe used in the manuscript.</a:t>
+            </a:r>
+            <a:endParaRPr lang="en-US" dirty="0"/>
+          </a:p>
+        </p:txBody>
+      </p:sp>
+      <p:sp>
+        <p:nvSpPr>
+          <p:cNvPr id="4" name="Slide Number Placeholder 3"/>
+          <p:cNvSpPr>
+            <a:spLocks noGrp="1"/>
+          </p:cNvSpPr>
+          <p:nvPr>
+            <p:ph type="sldNum" sz="quarter" idx="10"/>
+          </p:nvPr>
+        </p:nvSpPr>
+        <p:spPr/>
+        <p:txBody>
+          <a:bodyPr/>
+          <a:lstStyle/>
+          <a:p>
+            <a:fld id="{F7021451-1387-4CA6-816F-3879F97B5CBC}" type="slidenum">
+              <a:rPr lang="en-US"/>
+              <a:t>19</a:t>
             </a:fld>
             <a:endParaRPr lang="en-US"/>
           </a:p>
@@ -8760,7 +8853,7 @@
                   <a:schemeClr val="tx1"/>
                 </a:solidFill>
               </a:rPr>
-              <a:t>Two differences that turned out to be accessibility</a:t>
+              <a:t>Is it just that Dynamic sites are less accessible?</a:t>
             </a:r>
             <a:endParaRPr lang="en-US" sz="2800" dirty="0"/>
           </a:p>
@@ -8805,7 +8898,7 @@
                   <a:srgbClr val="111111"/>
                 </a:solidFill>
               </a:rPr>
-              <a:t>A second AP-1 copy looked worth more to Dynamic sites</a:t>
+              <a:t>Immune by design — both numbers come from the same window of the same site, so accessibility cancels</a:t>
             </a:r>
             <a:endParaRPr lang="en-US" sz="1700" dirty="0"/>
           </a:p>
@@ -8823,7 +8916,7 @@
                   <a:srgbClr val="595959"/>
                 </a:solidFill>
               </a:rPr>
-              <a:t>+0.72 vs +0.60 log2, p &lt; 1e-4 — matched on accessibility, p = 0.93. Gone.</a:t>
+              <a:t>Motif specificity · partner share. Partners are also net of a width- and distance-matched footprint-free control at the mirrored distance. No between-class matching needed, and none done.</a:t>
             </a:r>
             <a:endParaRPr lang="en-US" sz="1700" dirty="0"/>
           </a:p>
@@ -8844,7 +8937,7 @@
                   <a:srgbClr val="111111"/>
                 </a:solidFill>
               </a:rPr>
-              <a:t>Upgrading an imperfect core to a perfect TGAGTCA looked worth more to Dynamic sites</a:t>
+              <a:t>Accessibility is in the model, not matched out</a:t>
             </a:r>
             <a:endParaRPr lang="en-US" sz="1700" dirty="0"/>
           </a:p>
@@ -8862,7 +8955,7 @@
                   <a:srgbClr val="595959"/>
                 </a:solidFill>
               </a:rPr>
-              <a:t>+0.66 vs +0.52, p &lt; 1e-4 — matched, p = 0.94. Gone.</a:t>
+              <a:t>The swap: each class's regression conditions on both the donor's and the recipient's own native level, so the carried share is already net of the gap.</a:t>
             </a:r>
             <a:endParaRPr lang="en-US" sz="1700" dirty="0"/>
           </a:p>
@@ -8883,7 +8976,7 @@
                   <a:srgbClr val="111111"/>
                 </a:solidFill>
               </a:rPr>
-              <a:t>What did survive matching</a:t>
+              <a:t>Matched explicitly, and survived</a:t>
             </a:r>
             <a:endParaRPr lang="en-US" sz="1700" dirty="0"/>
           </a:p>
@@ -8901,7 +8994,7 @@
                   <a:srgbClr val="595959"/>
                 </a:solidFill>
               </a:rPr>
-              <a:t>Destroying the motif costs Dynamic sites less (+0.16, p = 4e-4); the dose-response is shallower; relocating the motif helps them less.</a:t>
+              <a:t>Importance density: 33.8% vs 30.7% unmatched, and 33.1% vs 31.3% over 860 pairs matched on predicted accessibility (caliper 0.1 log10), +1.5 points, P = 0.006.</a:t>
             </a:r>
             <a:endParaRPr lang="en-US" sz="1700" dirty="0"/>
           </a:p>
@@ -8922,7 +9015,7 @@
                   <a:srgbClr val="111111"/>
                 </a:solidFill>
               </a:rPr>
-              <a:t>Two clean negatives worth having</a:t>
+              <a:t>Checked, and only survives as a covariate adjustment</a:t>
             </a:r>
             <a:endParaRPr lang="en-US" sz="1700" dirty="0"/>
           </a:p>
@@ -8940,7 +9033,28 @@
                   <a:srgbClr val="595959"/>
                 </a:solidFill>
               </a:rPr>
-              <a:t>Reverse-complementing the whole motif costs nothing in either class (-0.03 log2, p = 0.89) — expected for a palindromic TRE, and a sanity check on the head.</a:t>
+              <a:t>Transplant: every element goes into the same 20 hosts, so the host cancels — but the donor classes are not matched. 1:1 matching leaves only 47 pairs and is not significant (P = 0.13). The covariate-adjusted gap is: +0.84 ± 0.30 log2, about 1.8x, P = 0.005. Quote that one.</a:t>
+            </a:r>
+            <a:endParaRPr lang="en-US" sz="1700" dirty="0"/>
+          </a:p>
+          <a:p>
+            <a:pPr algn="l" marL="342900" indent="-342900">
+              <a:spcBef>
+                <a:spcPts val="1100"/>
+              </a:spcBef>
+              <a:spcAft>
+                <a:spcPts val="300"/>
+              </a:spcAft>
+              <a:buSzPct val="100000"/>
+              <a:buChar char="•"/>
+            </a:pPr>
+            <a:r>
+              <a:rPr lang="en-US" sz="1700" b="1" dirty="0">
+                <a:solidFill>
+                  <a:srgbClr val="111111"/>
+                </a:solidFill>
+              </a:rPr>
+              <a:t>Checked, and did not survive</a:t>
             </a:r>
             <a:endParaRPr lang="en-US" sz="1700" dirty="0"/>
           </a:p>
@@ -8958,7 +9072,7 @@
                   <a:srgbClr val="595959"/>
                 </a:solidFill>
               </a:rPr>
-              <a:t>The spacing preference for a second copy is identical: best at ±20–40 bp, decaying by ±150 bp, with no class difference at any distance (all FDR &gt; 0.58).</a:t>
+              <a:t>Top tile is a core tile: 56% vs 52% raw, matched McNemar P = 0.21 — reported as a shared fact, not a class difference. Plus the two titration results on the next slide.</a:t>
             </a:r>
             <a:endParaRPr lang="en-US" sz="1700" dirty="0"/>
           </a:p>
@@ -9066,7 +9180,7 @@
                   <a:schemeClr val="tx1"/>
                 </a:solidFill>
               </a:rPr>
-              <a:t>How this sits with the MPRA work</a:t>
+              <a:t>Two differences that turned out to be accessibility</a:t>
             </a:r>
             <a:endParaRPr lang="en-US" sz="2800" dirty="0"/>
           </a:p>
@@ -9111,7 +9225,7 @@
                   <a:srgbClr val="111111"/>
                 </a:solidFill>
               </a:rPr>
-              <a:t>Agrees</a:t>
+              <a:t>A second AP-1 copy looked worth more to Dynamic sites</a:t>
             </a:r>
             <a:endParaRPr lang="en-US" sz="1700" dirty="0"/>
           </a:p>
@@ -9129,61 +9243,7 @@
                   <a:srgbClr val="595959"/>
                 </a:solidFill>
               </a:rPr>
-              <a:t>Dynamic elements have weaker endogenous chromatin, and depend on context rather than being sequence-autonomous.</a:t>
-            </a:r>
-            <a:endParaRPr lang="en-US" sz="1700" dirty="0"/>
-          </a:p>
-          <a:p>
-            <a:pPr algn="l" lvl="1" marL="685800" indent="-342900">
-              <a:spcAft>
-                <a:spcPts val="400"/>
-              </a:spcAft>
-              <a:buSzPct val="100000"/>
-              <a:buChar char="▪"/>
-            </a:pPr>
-            <a:r>
-              <a:rPr lang="en-US" sz="1450" dirty="0">
-                <a:solidFill>
-                  <a:srgbClr val="595959"/>
-                </a:solidFill>
-              </a:rPr>
-              <a:t>Shuffling the AP-1 core alone does not separate pooled Stable from pooled Dynamic.</a:t>
-            </a:r>
-            <a:endParaRPr lang="en-US" sz="1700" dirty="0"/>
-          </a:p>
-          <a:p>
-            <a:pPr algn="l" lvl="1" marL="685800" indent="-342900">
-              <a:spcAft>
-                <a:spcPts val="400"/>
-              </a:spcAft>
-              <a:buSzPct val="100000"/>
-              <a:buChar char="▪"/>
-            </a:pPr>
-            <a:r>
-              <a:rPr lang="en-US" sz="1450" dirty="0">
-                <a:solidFill>
-                  <a:srgbClr val="595959"/>
-                </a:solidFill>
-              </a:rPr>
-              <a:t>Age-gained elements behave like Stable ones — here, at their own AP-1 motif.</a:t>
-            </a:r>
-            <a:endParaRPr lang="en-US" sz="1700" dirty="0"/>
-          </a:p>
-          <a:p>
-            <a:pPr algn="l" lvl="1" marL="685800" indent="-342900">
-              <a:spcAft>
-                <a:spcPts val="400"/>
-              </a:spcAft>
-              <a:buSzPct val="100000"/>
-              <a:buChar char="▪"/>
-            </a:pPr>
-            <a:r>
-              <a:rPr lang="en-US" sz="1450" dirty="0">
-                <a:solidFill>
-                  <a:srgbClr val="595959"/>
-                </a:solidFill>
-              </a:rPr>
-              <a:t>C/EBP is the strongest partner motif at fibroblast AP-1 sites (net −0.71 log2, ahead of MEF2 and NFI).</a:t>
+              <a:t>+0.72 vs +0.60 log2, p &lt; 1e-4 — matched on accessibility, p = 0.93. Gone.</a:t>
             </a:r>
             <a:endParaRPr lang="en-US" sz="1700" dirty="0"/>
           </a:p>
@@ -9204,7 +9264,7 @@
                   <a:srgbClr val="111111"/>
                 </a:solidFill>
               </a:rPr>
-              <a:t>Adds</a:t>
+              <a:t>Upgrading an imperfect core to a perfect TGAGTCA looked worth more to Dynamic sites</a:t>
             </a:r>
             <a:endParaRPr lang="en-US" sz="1700" dirty="0"/>
           </a:p>
@@ -9222,61 +9282,7 @@
                   <a:srgbClr val="595959"/>
                 </a:solidFill>
               </a:rPr>
-              <a:t>The class difference is a whole-peak property, not a 170 bp one.</a:t>
-            </a:r>
-            <a:endParaRPr lang="en-US" sz="1700" dirty="0"/>
-          </a:p>
-          <a:p>
-            <a:pPr algn="l" lvl="1" marL="685800" indent="-342900">
-              <a:spcAft>
-                <a:spcPts val="400"/>
-              </a:spcAft>
-              <a:buSzPct val="100000"/>
-              <a:buChar char="▪"/>
-            </a:pPr>
-            <a:r>
-              <a:rPr lang="en-US" sz="1450" dirty="0">
-                <a:solidFill>
-                  <a:srgbClr val="595959"/>
-                </a:solidFill>
-              </a:rPr>
-              <a:t>Within Dynamic, the AP-1-LOSING sites are the ones that are sequence-different, with age and with exercise alike; the gaining ones look like Stable. Direction, not stimulus.</a:t>
-            </a:r>
-            <a:endParaRPr lang="en-US" sz="1700" dirty="0"/>
-          </a:p>
-          <a:p>
-            <a:pPr algn="l" lvl="1" marL="685800" indent="-342900">
-              <a:spcAft>
-                <a:spcPts val="400"/>
-              </a:spcAft>
-              <a:buSzPct val="100000"/>
-              <a:buChar char="▪"/>
-            </a:pPr>
-            <a:r>
-              <a:rPr lang="en-US" sz="1450" dirty="0">
-                <a:solidFill>
-                  <a:srgbClr val="595959"/>
-                </a:solidFill>
-              </a:rPr>
-              <a:t>Unprompted, AlphaGenome makes the AP-1 core the most important 10 bp in over half of all sites — equally in both classes. The classes differ in how much of the dependence sits there, not in whether AP-1 leads.</a:t>
-            </a:r>
-            <a:endParaRPr lang="en-US" sz="1700" dirty="0"/>
-          </a:p>
-          <a:p>
-            <a:pPr algn="l" lvl="1" marL="685800" indent="-342900">
-              <a:spcAft>
-                <a:spcPts val="400"/>
-              </a:spcAft>
-              <a:buSzPct val="100000"/>
-              <a:buChar char="▪"/>
-            </a:pPr>
-            <a:r>
-              <a:rPr lang="en-US" sz="1450" dirty="0">
-                <a:solidFill>
-                  <a:srgbClr val="595959"/>
-                </a:solidFill>
-              </a:rPr>
-              <a:t>Dynamic sites spread their dependence slightly wider, and it survives accessibility matching (33.1% vs 31.3% within ±25 bp, P = 0.006) — the sequence-model version of “attention is more distributed at dynamic enhancers”.</a:t>
+              <a:t>+0.66 vs +0.52, p &lt; 1e-4 — matched, p = 0.94. Gone.</a:t>
             </a:r>
             <a:endParaRPr lang="en-US" sz="1700" dirty="0"/>
           </a:p>
@@ -9297,7 +9303,7 @@
                   <a:srgbClr val="111111"/>
                 </a:solidFill>
               </a:rPr>
-              <a:t>Keep off the slides</a:t>
+              <a:t>What did survive matching</a:t>
             </a:r>
             <a:endParaRPr lang="en-US" sz="1700" dirty="0"/>
           </a:p>
@@ -9315,7 +9321,64 @@
                   <a:srgbClr val="595959"/>
                 </a:solidFill>
               </a:rPr>
-              <a:t>Our in-situ 170 bp shuffle costs Stable sites more (−2.51 vs −1.96, p = 4e-40), the opposite of the MPRA flank result. Different assay — episomal activity vs chromatin accessibility — but it reads as a contradiction.</a:t>
+              <a:t>Destroying the motif costs Dynamic sites less (+0.16, p = 4e-4); the dose-response is shallower; relocating the motif helps them less.</a:t>
+            </a:r>
+            <a:endParaRPr lang="en-US" sz="1700" dirty="0"/>
+          </a:p>
+          <a:p>
+            <a:pPr algn="l" marL="342900" indent="-342900">
+              <a:spcBef>
+                <a:spcPts val="1100"/>
+              </a:spcBef>
+              <a:spcAft>
+                <a:spcPts val="300"/>
+              </a:spcAft>
+              <a:buSzPct val="100000"/>
+              <a:buChar char="•"/>
+            </a:pPr>
+            <a:r>
+              <a:rPr lang="en-US" sz="1700" b="1" dirty="0">
+                <a:solidFill>
+                  <a:srgbClr val="111111"/>
+                </a:solidFill>
+              </a:rPr>
+              <a:t>Two clean negatives worth having</a:t>
+            </a:r>
+            <a:endParaRPr lang="en-US" sz="1700" dirty="0"/>
+          </a:p>
+          <a:p>
+            <a:pPr algn="l" lvl="1" marL="685800" indent="-342900">
+              <a:spcAft>
+                <a:spcPts val="400"/>
+              </a:spcAft>
+              <a:buSzPct val="100000"/>
+              <a:buChar char="▪"/>
+            </a:pPr>
+            <a:r>
+              <a:rPr lang="en-US" sz="1450" dirty="0">
+                <a:solidFill>
+                  <a:srgbClr val="595959"/>
+                </a:solidFill>
+              </a:rPr>
+              <a:t>Reverse-complementing the whole motif costs nothing in either class (-0.03 log2, p = 0.89) — expected for a palindromic TRE, and a sanity check on the head.</a:t>
+            </a:r>
+            <a:endParaRPr lang="en-US" sz="1700" dirty="0"/>
+          </a:p>
+          <a:p>
+            <a:pPr algn="l" lvl="1" marL="685800" indent="-342900">
+              <a:spcAft>
+                <a:spcPts val="400"/>
+              </a:spcAft>
+              <a:buSzPct val="100000"/>
+              <a:buChar char="▪"/>
+            </a:pPr>
+            <a:r>
+              <a:rPr lang="en-US" sz="1450" dirty="0">
+                <a:solidFill>
+                  <a:srgbClr val="595959"/>
+                </a:solidFill>
+              </a:rPr>
+              <a:t>The spacing preference for a second copy is identical: best at ±20–40 bp, decaying by ±150 bp, with no class difference at any distance (all FDR &gt; 0.58).</a:t>
             </a:r>
             <a:endParaRPr lang="en-US" sz="1700" dirty="0"/>
           </a:p>
@@ -9361,6 +9424,363 @@
             <a:fld id="{F7021451-1387-4CA6-816F-3879F97B5CBC}" type="slidenum">
               <a:rPr b="0" lang="en-US"/>
               <a:t>18</a:t>
+            </a:fld>
+            <a:endParaRPr lang="en-US"/>
+          </a:p>
+        </p:txBody>
+      </p:sp>
+    </p:spTree>
+  </p:cSld>
+  <p:clrMapOvr>
+    <a:masterClrMapping/>
+  </p:clrMapOvr>
+</p:sld>
+</file>
+
+<file path=ppt/slides/slide19.xml><?xml version="1.0" encoding="utf-8"?>
+<p:sld xmlns:a="http://schemas.openxmlformats.org/drawingml/2006/main" xmlns:r="http://schemas.openxmlformats.org/officeDocument/2006/relationships" xmlns:p="http://schemas.openxmlformats.org/presentationml/2006/main">
+  <p:cSld name="Slide 19">
+    <p:spTree>
+      <p:nvGrpSpPr>
+        <p:cNvPr id="1" name=""/>
+        <p:cNvGrpSpPr/>
+        <p:nvPr/>
+      </p:nvGrpSpPr>
+      <p:grpSpPr>
+        <a:xfrm>
+          <a:off x="0" y="0"/>
+          <a:ext cx="0" cy="0"/>
+          <a:chOff x="0" y="0"/>
+          <a:chExt cx="0" cy="0"/>
+        </a:xfrm>
+      </p:grpSpPr>
+      <p:sp>
+        <p:nvSpPr>
+          <p:cNvPr id="2" name="Text 0"/>
+          <p:cNvSpPr/>
+          <p:nvPr>
+            <p:ph idx="100" type="title" hasCustomPrompt="1"/>
+          </p:nvPr>
+        </p:nvSpPr>
+        <p:spPr>
+          <a:xfrm>
+            <a:off x="502920" y="274320"/>
+            <a:ext cx="11155680" cy="731520"/>
+          </a:xfrm>
+          <a:prstGeom prst="rect">
+            <a:avLst/>
+          </a:prstGeom>
+          <a:noFill/>
+          <a:ln/>
+        </p:spPr>
+        <p:txBody>
+          <a:bodyPr wrap="square" rtlCol="0" anchor="ctr"/>
+          <a:lstStyle/>
+          <a:p>
+            <a:pPr algn="l" indent="0" marL="0">
+              <a:buNone/>
+            </a:pPr>
+            <a:r>
+              <a:rPr lang="en-US" sz="2800" b="1" dirty="0">
+                <a:solidFill>
+                  <a:schemeClr val="tx1"/>
+                </a:solidFill>
+              </a:rPr>
+              <a:t>How this sits with the MPRA work</a:t>
+            </a:r>
+            <a:endParaRPr lang="en-US" sz="2800" dirty="0"/>
+          </a:p>
+        </p:txBody>
+      </p:sp>
+      <p:sp>
+        <p:nvSpPr>
+          <p:cNvPr id="3" name="Text 0"/>
+          <p:cNvSpPr/>
+          <p:nvPr>
+            <p:ph idx="101" type="body" hasCustomPrompt="1"/>
+          </p:nvPr>
+        </p:nvSpPr>
+        <p:spPr>
+          <a:xfrm>
+            <a:off x="502920" y="1234440"/>
+            <a:ext cx="11155680" cy="5029200"/>
+          </a:xfrm>
+          <a:prstGeom prst="rect">
+            <a:avLst/>
+          </a:prstGeom>
+          <a:noFill/>
+          <a:ln/>
+        </p:spPr>
+        <p:txBody>
+          <a:bodyPr wrap="square" rtlCol="0" anchor="t"/>
+          <a:lstStyle/>
+          <a:p>
+            <a:pPr algn="l" marL="342900" indent="-342900">
+              <a:spcBef>
+                <a:spcPts val="1100"/>
+              </a:spcBef>
+              <a:spcAft>
+                <a:spcPts val="300"/>
+              </a:spcAft>
+              <a:buSzPct val="100000"/>
+              <a:buChar char="•"/>
+            </a:pPr>
+            <a:r>
+              <a:rPr lang="en-US" sz="1700" b="1" dirty="0">
+                <a:solidFill>
+                  <a:srgbClr val="111111"/>
+                </a:solidFill>
+              </a:rPr>
+              <a:t>Agrees</a:t>
+            </a:r>
+            <a:endParaRPr lang="en-US" sz="1700" dirty="0"/>
+          </a:p>
+          <a:p>
+            <a:pPr algn="l" lvl="1" marL="685800" indent="-342900">
+              <a:spcAft>
+                <a:spcPts val="400"/>
+              </a:spcAft>
+              <a:buSzPct val="100000"/>
+              <a:buChar char="▪"/>
+            </a:pPr>
+            <a:r>
+              <a:rPr lang="en-US" sz="1450" dirty="0">
+                <a:solidFill>
+                  <a:srgbClr val="595959"/>
+                </a:solidFill>
+              </a:rPr>
+              <a:t>Dynamic elements have weaker endogenous chromatin, and depend on context rather than being sequence-autonomous.</a:t>
+            </a:r>
+            <a:endParaRPr lang="en-US" sz="1700" dirty="0"/>
+          </a:p>
+          <a:p>
+            <a:pPr algn="l" lvl="1" marL="685800" indent="-342900">
+              <a:spcAft>
+                <a:spcPts val="400"/>
+              </a:spcAft>
+              <a:buSzPct val="100000"/>
+              <a:buChar char="▪"/>
+            </a:pPr>
+            <a:r>
+              <a:rPr lang="en-US" sz="1450" dirty="0">
+                <a:solidFill>
+                  <a:srgbClr val="595959"/>
+                </a:solidFill>
+              </a:rPr>
+              <a:t>Shuffling the AP-1 core alone does not separate pooled Stable from pooled Dynamic.</a:t>
+            </a:r>
+            <a:endParaRPr lang="en-US" sz="1700" dirty="0"/>
+          </a:p>
+          <a:p>
+            <a:pPr algn="l" lvl="1" marL="685800" indent="-342900">
+              <a:spcAft>
+                <a:spcPts val="400"/>
+              </a:spcAft>
+              <a:buSzPct val="100000"/>
+              <a:buChar char="▪"/>
+            </a:pPr>
+            <a:r>
+              <a:rPr lang="en-US" sz="1450" dirty="0">
+                <a:solidFill>
+                  <a:srgbClr val="595959"/>
+                </a:solidFill>
+              </a:rPr>
+              <a:t>Age-gained elements behave like Stable ones — here, at their own AP-1 motif.</a:t>
+            </a:r>
+            <a:endParaRPr lang="en-US" sz="1700" dirty="0"/>
+          </a:p>
+          <a:p>
+            <a:pPr algn="l" lvl="1" marL="685800" indent="-342900">
+              <a:spcAft>
+                <a:spcPts val="400"/>
+              </a:spcAft>
+              <a:buSzPct val="100000"/>
+              <a:buChar char="▪"/>
+            </a:pPr>
+            <a:r>
+              <a:rPr lang="en-US" sz="1450" dirty="0">
+                <a:solidFill>
+                  <a:srgbClr val="595959"/>
+                </a:solidFill>
+              </a:rPr>
+              <a:t>C/EBP is the strongest partner motif at fibroblast AP-1 sites (net −0.71 log2, ahead of MEF2 and NFI).</a:t>
+            </a:r>
+            <a:endParaRPr lang="en-US" sz="1700" dirty="0"/>
+          </a:p>
+          <a:p>
+            <a:pPr algn="l" marL="342900" indent="-342900">
+              <a:spcBef>
+                <a:spcPts val="1100"/>
+              </a:spcBef>
+              <a:spcAft>
+                <a:spcPts val="300"/>
+              </a:spcAft>
+              <a:buSzPct val="100000"/>
+              <a:buChar char="•"/>
+            </a:pPr>
+            <a:r>
+              <a:rPr lang="en-US" sz="1700" b="1" dirty="0">
+                <a:solidFill>
+                  <a:srgbClr val="111111"/>
+                </a:solidFill>
+              </a:rPr>
+              <a:t>Adds</a:t>
+            </a:r>
+            <a:endParaRPr lang="en-US" sz="1700" dirty="0"/>
+          </a:p>
+          <a:p>
+            <a:pPr algn="l" lvl="1" marL="685800" indent="-342900">
+              <a:spcAft>
+                <a:spcPts val="400"/>
+              </a:spcAft>
+              <a:buSzPct val="100000"/>
+              <a:buChar char="▪"/>
+            </a:pPr>
+            <a:r>
+              <a:rPr lang="en-US" sz="1450" dirty="0">
+                <a:solidFill>
+                  <a:srgbClr val="595959"/>
+                </a:solidFill>
+              </a:rPr>
+              <a:t>The class difference is a whole-peak property, not a 170 bp one.</a:t>
+            </a:r>
+            <a:endParaRPr lang="en-US" sz="1700" dirty="0"/>
+          </a:p>
+          <a:p>
+            <a:pPr algn="l" lvl="1" marL="685800" indent="-342900">
+              <a:spcAft>
+                <a:spcPts val="400"/>
+              </a:spcAft>
+              <a:buSzPct val="100000"/>
+              <a:buChar char="▪"/>
+            </a:pPr>
+            <a:r>
+              <a:rPr lang="en-US" sz="1450" dirty="0">
+                <a:solidFill>
+                  <a:srgbClr val="595959"/>
+                </a:solidFill>
+              </a:rPr>
+              <a:t>Within Dynamic, the AP-1-LOSING sites are the ones that are sequence-different, with age and with exercise alike; the gaining ones look like Stable. Direction, not stimulus.</a:t>
+            </a:r>
+            <a:endParaRPr lang="en-US" sz="1700" dirty="0"/>
+          </a:p>
+          <a:p>
+            <a:pPr algn="l" lvl="1" marL="685800" indent="-342900">
+              <a:spcAft>
+                <a:spcPts val="400"/>
+              </a:spcAft>
+              <a:buSzPct val="100000"/>
+              <a:buChar char="▪"/>
+            </a:pPr>
+            <a:r>
+              <a:rPr lang="en-US" sz="1450" dirty="0">
+                <a:solidFill>
+                  <a:srgbClr val="595959"/>
+                </a:solidFill>
+              </a:rPr>
+              <a:t>Unprompted, AlphaGenome makes the AP-1 core the most important 10 bp in over half of all sites — equally in both classes. The classes differ in how much of the dependence sits there, not in whether AP-1 leads.</a:t>
+            </a:r>
+            <a:endParaRPr lang="en-US" sz="1700" dirty="0"/>
+          </a:p>
+          <a:p>
+            <a:pPr algn="l" lvl="1" marL="685800" indent="-342900">
+              <a:spcAft>
+                <a:spcPts val="400"/>
+              </a:spcAft>
+              <a:buSzPct val="100000"/>
+              <a:buChar char="▪"/>
+            </a:pPr>
+            <a:r>
+              <a:rPr lang="en-US" sz="1450" dirty="0">
+                <a:solidFill>
+                  <a:srgbClr val="595959"/>
+                </a:solidFill>
+              </a:rPr>
+              <a:t>Dynamic sites spread their dependence slightly wider, and it survives accessibility matching (33.1% vs 31.3% within ±25 bp, P = 0.006) — the sequence-model version of “attention is more distributed at dynamic enhancers”.</a:t>
+            </a:r>
+            <a:endParaRPr lang="en-US" sz="1700" dirty="0"/>
+          </a:p>
+          <a:p>
+            <a:pPr algn="l" marL="342900" indent="-342900">
+              <a:spcBef>
+                <a:spcPts val="1100"/>
+              </a:spcBef>
+              <a:spcAft>
+                <a:spcPts val="300"/>
+              </a:spcAft>
+              <a:buSzPct val="100000"/>
+              <a:buChar char="•"/>
+            </a:pPr>
+            <a:r>
+              <a:rPr lang="en-US" sz="1700" b="1" dirty="0">
+                <a:solidFill>
+                  <a:srgbClr val="111111"/>
+                </a:solidFill>
+              </a:rPr>
+              <a:t>Keep off the slides</a:t>
+            </a:r>
+            <a:endParaRPr lang="en-US" sz="1700" dirty="0"/>
+          </a:p>
+          <a:p>
+            <a:pPr algn="l" lvl="1" marL="685800" indent="-342900">
+              <a:spcAft>
+                <a:spcPts val="400"/>
+              </a:spcAft>
+              <a:buSzPct val="100000"/>
+              <a:buChar char="▪"/>
+            </a:pPr>
+            <a:r>
+              <a:rPr lang="en-US" sz="1450" dirty="0">
+                <a:solidFill>
+                  <a:srgbClr val="595959"/>
+                </a:solidFill>
+              </a:rPr>
+              <a:t>Our in-situ 170 bp shuffle costs Stable sites more (−2.51 vs −1.96, p = 4e-40), the opposite of the MPRA flank result. Different assay — episomal activity vs chromatin accessibility — but it reads as a contradiction.</a:t>
+            </a:r>
+            <a:endParaRPr lang="en-US" sz="1700" dirty="0"/>
+          </a:p>
+        </p:txBody>
+      </p:sp>
+      <p:sp>
+        <p:nvSpPr>
+          <p:cNvPr id="25" name="Slide Number Placeholder 0"/>
+          <p:cNvSpPr>
+            <a:spLocks noGrp="1"/>
+          </p:cNvSpPr>
+          <p:nvPr>
+            <p:ph type="sldNum" sz="quarter" idx="4294967295"/>
+          </p:nvPr>
+        </p:nvSpPr>
+        <p:spPr>
+          <a:xfrm>
+            <a:off x="11658600" y="6446520"/>
+            <a:ext cx="800000" cy="300000"/>
+          </a:xfrm>
+          <a:prstGeom prst="rect">
+            <a:avLst/>
+          </a:prstGeom>
+          <a:extLst>
+            <a:ext uri="{C572A759-6A51-4108-AA02-DFA0A04FC94B}">
+              <ma14:wrappingTextBoxFlag xmlns:ma14="http://schemas.microsoft.com/office/mac/drawingml/2011/main" val="0"/>
+            </a:ext>
+          </a:extLst>
+        </p:spPr>
+        <p:txBody>
+          <a:bodyPr/>
+          <a:lstStyle>
+            <a:lvl1pPr>
+              <a:defRPr sz="1000">
+                <a:solidFill>
+                  <a:srgbClr val="A6A6A6"/>
+                </a:solidFill>
+              </a:defRPr>
+            </a:lvl1pPr>
+          </a:lstStyle>
+          <a:p>
+            <a:pPr algn="l"/>
+            <a:fld id="{F7021451-1387-4CA6-816F-3879F97B5CBC}" type="slidenum">
+              <a:rPr b="0" lang="en-US"/>
+              <a:t>19</a:t>
             </a:fld>
             <a:endParaRPr lang="en-US"/>
           </a:p>

</xml_diff>

<commit_message>
Transplant against the empty host, at both widths: it scales
The hosts are closed (0.0078 against 4.78 for a real site) but a
scrambled insert is not neutral - it opens them 3.3x on its own, the
same in every class. So the old scramble baseline understated the
insertion without changing the class comparison: 4.7x apart against
the scramble, 5.0x against the empty host.

Shown at both transplanted widths, because it is not binary. Every
doubling of transplanted sequence multiplies a Stable element by 2.2x
and a Dynamic one by 1.4x; at 170 bp the classes are 1.4x apart, at
whole peak 5.0x. Same message the swap slide reaches from the other
side.

Co-Authored-By: Claude Opus 5 <noreply@anthropic.com>
</commit_message>
<xml_diff>
--- a/Analysis/AP1_fibroblast_lab_meeting.pptx
+++ b/Analysis/AP1_fibroblast_lab_meeting.pptx
@@ -1806,9 +1806,19 @@
           <a:p>
             <a:r>
               <a:rPr lang="en-US" dirty="0"/>
-              <a:t>Per-donor medians over 20 hosts: Stable +4.65 log2 (25x), Dynamic pooled +2.35 (5.1x), p = 1.5e-5.
-By class, as plotted: Stable 25x, Age Up 6.3x, Age Down 6.1x, Exercise Down 4.6x, Exercise Up 4.4x. Every Dynamic class sits well below Stable and they are close to each other, which is why pooling them is fair here.
-IMPORTANT CAVEAT, be ready for this question: the donors are not matched on accessibility - Stable donors come from loci about 1.8x more accessible (measured ATAC: 32.2 vs 18.0 CPM/kb). Matching on MEASURED fibroblast ATAC (model-independent), the residual Stable advantage is +0.84 +- 0.30 log2, i.e. about 1.8x, p = 0.005 (covariance adjustment, 224 donors). The 47 matched pairs point the same way (+0.99) but are underpowered (p = 0.13). So: direction solid, magnitude about a third to a half of the raw gap. Do not defend 25x vs 5x as a sequence effect.
+              <a:t>THE BASELINE CHANGED, and it matters. This used to be scored against a dinucleotide-shuffled copy of the element in the same host. 20_host_native.py predicted the hosts empty for the first time and showed two things:
+  - the hosts really are closed: 0.0078 predicted accessibility, against 4.78 for a real AP-1 site in its own locus, about 600x lower. The 'closed background' assumption now has evidence behind it.
+  - a scrambled insert is NOT neutral: it opens these hosts about 3.3x on its own. So the old contrast understated what inserting an element does.
+The scramble effect is the same in every class (3.4x Stable vs 3.3x Dynamic, p = 0.46 at peak width), so the CLASS comparison barely moves: 4.7x apart against the scramble, 5.0x against the empty host. Only the absolute numbers change, and they roughly triple.
+NUMBERS, fold over the empty host:
+  170 bp   Stable 8.1x · Age Down 6.5x · Exercise Down 5.8x · Exercise Up 5.5x · Age Up 5.4x   (Stable vs Dynamic 1.4x, p = 0.002)
+  peak     Stable 64.7x · Age Up 18.8x · Age Down 16.6x · Exercise Down 11.6x · Exercise Up 10.8x   (5.0x, p = 0.00019)
+Scaling slope, per doubling of transplanted bp: Stable 1.17 in log2 (2.2x), Dynamic 0.48 (1.4x).
+Against the scramble, if anyone wants the conservative version: peak width Stable 22.8x vs Dynamic 4.9x, p = 1.7e-5.
+Two things to have ready:
+  - Stable peaks are slightly wider (median 1,000 vs 900 bp) so they do get marginally more sequence, but the difference is 11% and not significant (p = 0.16), nowhere near enough to make a 5-fold gap.
+  - at 170 bp the scramble control is itself class-dependent (3.7x vs 3.3x, p = 0.012), which it is not at peak width. Another reason the 170 bp row is the weaker readout, beyond being the smaller effect.
+This is the same conclusion the swap slide reaches from the other direction: at 170 bp almost nothing transfers, at peak width the element carries 73-84% of its own level. Two designs, one message - what opens the chromatin is spread across the whole peak, which is why a 170 bp assay struggles to see it.
 Also worth knowing: 0 of 50 Stable donors lack a measured ATAC peak, against 5-8 per Dynamic class.</a:t>
             </a:r>
             <a:endParaRPr lang="en-US" dirty="0"/>
@@ -17379,7 +17389,7 @@
                   <a:schemeClr val="tx1"/>
                 </a:solidFill>
               </a:rPr>
-              <a:t>A Stable element opens closed chromatin on its own</a:t>
+              <a:t>The more of a Stable element you move, the more it builds</a:t>
             </a:r>
             <a:endParaRPr lang="en-US" sz="2800" dirty="0"/>
           </a:p>
@@ -17415,7 +17425,7 @@
                   <a:srgbClr val="595959"/>
                 </a:solidFill>
               </a:rPr>
-              <a:t>Each element moved into 20 closed backgrounds and scored against the same sequence shuffled; one point per donor, whole-peak width. Box, median and IQR, whiskers 1.5 × IQR; 50 donors per class — Up = AP-1 gained, Down = AP-1 lost; Mann–Whitney, Stable against the four Dynamic classes pooled.</a:t>
+              <a:t>Each element written into the centre of the same 20 closed hosts, scored against that host left empty — a true no-insert baseline. Two widths: the 170 bp MPRA window and the whole peak (median 930 bp). Median over 20 hosts per donor, then over 50 donors per class; bars bootstrap 95% CI. Both axes log.</a:t>
             </a:r>
             <a:endParaRPr lang="en-US" sz="1250" dirty="0"/>
           </a:p>
@@ -17437,8 +17447,8 @@
         </p:blipFill>
         <p:spPr>
           <a:xfrm>
-            <a:off x="1171501" y="1335024"/>
-            <a:ext cx="9818518" cy="3566160"/>
+            <a:off x="1468033" y="1335024"/>
+            <a:ext cx="9225454" cy="3566160"/>
           </a:xfrm>
           <a:prstGeom prst="rect">
             <a:avLst/>
@@ -17500,7 +17510,7 @@
                   <a:srgbClr val="111111"/>
                 </a:solidFill>
               </a:rPr>
-              <a:t>Stable AP-1 elements carry enough sequence to build their own accessible site. Dynamic ones do not — they need the neighbourhood they came from. That is "context, not sequence autonomy", shown by moving the sequence.</a:t>
+              <a:t>It is not all-or-nothing, it scales — and the two classes scale differently. Every doubling of transplanted sequence multiplies a Stable element's effect by 2.2× but a Dynamic one's by only 1.4×. At 170 bp the classes are nearly the same (8× against 6×); give them their whole peak and they are five-fold apart.</a:t>
             </a:r>
             <a:endParaRPr lang="en-US" sz="1700" dirty="0"/>
           </a:p>
@@ -17536,7 +17546,7 @@
                   <a:srgbClr val="595959"/>
                 </a:solidFill>
               </a:rPr>
-              <a:t>Stable donors also come from more accessible loci. Holding that constant (measured ATAC, 224 donors) a Stable element still gains 1.8× more than a Dynamic one, P = 0.005 — the direction holds, but about a third of the gap above is accessibility rather than sequence.</a:t>
+              <a:t>Stable donors also come from more accessible loci. Holding that constant (measured ATAC, 224 donors) a Stable element still gains 1.8× more than a Dynamic one, P = 0.005; the 47 strictly matched pairs point the same way but are underpowered (P = 0.13). Direction solid, and about a third of the raw gap is accessibility rather than sequence.</a:t>
             </a:r>
             <a:endParaRPr lang="en-US" sz="1300" dirty="0"/>
           </a:p>

</xml_diff>

<commit_message>
Which partner families each class leans on, besides AP-1
Ranked per class from the partner shuffle, where each footprint is
scored against a width- and distance-matched footprint-free window, so
the numbers are already net of disturbing that much sequence.

The same three lead everywhere (C/EBP, NFI, E-box bHLH). Three class
differences clear BH within class; only heat-shock motifs in Exercise
Down would survive adjusting across all classes, and the slide says so.

Not from the scan: a positional scan says which 10 bp matter, never
what is written there. Noted on the slide so the two are not confused.

Co-Authored-By: Claude Opus 5 <noreply@anthropic.com>
</commit_message>
<xml_diff>
--- a/Analysis/AP1_fibroblast_lab_meeting.pptx
+++ b/Analysis/AP1_fibroblast_lab_meeting.pptx
@@ -24,9 +24,10 @@
     <p:sldId id="272" r:id="rId18"/>
     <p:sldId id="273" r:id="rId19"/>
     <p:sldId id="274" r:id="rId20"/>
+    <p:sldId id="275" r:id="rId21"/>
   </p:sldIdLst>
   <p:notesMasterIdLst>
-    <p:notesMasterId r:id="rId21"/>
+    <p:notesMasterId r:id="rId22"/>
   </p:notesMasterIdLst>
   <p:sldSz cx="12192000" cy="6858000"/>
   <p:notesSz cx="6858000" cy="12192000"/>
@@ -1261,11 +1262,17 @@
           <a:p>
             <a:r>
               <a:rPr lang="en-US" dirty="0"/>
-              <a:t>Keep this one in the back pocket; it is the first question any of these results gets.
-The size of the confound: Stable sites are about twice as accessible as Dynamic ones (measured native 32.2 vs 18.0 in the swap donors; predicted 10.5 vs 8.5 across the scan sites).
-Two different things are matched on in different places, and it is worth being straight about it: the transplant matches on MEASURED native accessibility, the density and top-tile analyses on PREDICTED. Matching on predicted is the more conservative choice for a prediction-based readout, because it removes the thing the model itself would key on.
-Not matched, and said so on the slides: the three alternative density readings. The pooled Stable-vs-Dynamic contrast they re-draw is the one that survives matching; the five-class split has not been matched, because Exercise Down has 115 sites and would not support it.
-Why 1:1 matching keeps coming out underpowered: a caliper of 0.1 log10 on populations that differ roughly two-fold throws most of the Dynamic sites away. Where the n allows it (860 pairs in the scan) it is the better test; where it does not (47 donor pairs in the transplant) the covariate adjustment uses every site and is the one to quote.</a:t>
+              <a:t>Source: Scripts/62_fb_partner_families_by_class.py, from the per-site per-family net effects. AP-1 itself is excluded - it has its own slide. A family needs 25 sites in a class to be ranked there.
+FULL TOP-FIVE BY CLASS (net log2, share of that class's sites carrying the footprint):
+  Stable (1180): CEBP -0.69 (11.0%) · NFI -0.36 (28.0%) · E-box -0.27 (49.0%) · heat shock -0.19 (33.4%) · TEAD -0.16 (14.7%)
+  Age Up (613): CEBP -1.25 (4.2%) · NFI -0.89 (15.2%) · E-box -0.39 (33.0%) · TALE homeodomain -0.33 (4.2%) · heat shock -0.28 (18.9%)
+  Age Down (212): CTCF/cohesin -0.56 (15.1%) · NFI -0.38 (14.2%) · E-box -0.34 (30.7%) · heat shock -0.27 (26.4%) · ETS -0.20 (21.7%)
+  Exercise Up (240): NFI -0.70 (15.4%) · E-box -0.44 (21.2%) · heat shock -0.23 (17.1%) · NF-kB/Rel -0.22 (12.1%) · NFAT -0.20 (10.8%)
+  Exercise Down (115): heat shock -0.69 (24.3%) · E-box -0.51 (38.3%) · KLF/SP -0.10 (62.6%) · Other -0.09 (73.9%) · Zn finger -0.07 (66.1%)
+DO NOT quote CTCF/cohesin topping Age Down as a result. n = 32 and the interval is [-2.14, -0.15] - the point estimate is unstable and it does not differ from Stable (FDR 0.059).
+How this sits with the specificity slide: that one says no class differs at its partner motifs, pooling all families into one number per site, and that remains true. Splitting by family is a finer and much more multiply-tested question, and it turns up three isolated hits. The two statements are consistent; the per-family one is the weaker evidence.
+The heat-shock result in Exercise Down is the one worth a sentence out loud: the sites that lose AP-1 with exercise are the ones whose remaining dependence sits on stress-response motifs. That is a hypothesis the bench could test, not something this analysis establishes.
+If someone asks what the SLIDING SCAN says about other motifs: nothing directly, and it is still running. Once it lands, the analysis that would answer it is to intersect the significant 10 bp windows with the TOBIAS footprint positions and ask which families sit under the secondary peaks. Worth doing, not yet done.</a:t>
             </a:r>
             <a:endParaRPr lang="en-US" dirty="0"/>
           </a:p>
@@ -1353,8 +1360,11 @@
           <a:p>
             <a:r>
               <a:rPr lang="en-US" dirty="0"/>
-              <a:t>From the fibroblast titration, 2,359 sites, 860 accessibility-matched pairs (caliper 0.1 log10). This slide is the argument for why the matched analysis is worth doing - two of the five largest raw class differences in the titration were entirely explained by the accessibility gap.
-Age Down is the outlier again, consistently with the other arms: one base of the core changed -0.62 vs Stable -0.83; motif gone -0.72 vs -1.07.</a:t>
+              <a:t>Keep this one in the back pocket; it is the first question any of these results gets.
+The size of the confound: Stable sites are about twice as accessible as Dynamic ones (measured native 32.2 vs 18.0 in the swap donors; predicted 10.5 vs 8.5 across the scan sites).
+Two different things are matched on in different places, and it is worth being straight about it: the transplant matches on MEASURED native accessibility, the density and top-tile analyses on PREDICTED. Matching on predicted is the more conservative choice for a prediction-based readout, because it removes the thing the model itself would key on.
+Not matched, and said so on the slides: the three alternative density readings. The pooled Stable-vs-Dynamic contrast they re-draw is the one that survives matching; the five-class split has not been matched, because Exercise Down has 115 sites and would not support it.
+Why 1:1 matching keeps coming out underpowered: a caliper of 0.1 log10 on populations that differ roughly two-fold throws most of the Dynamic sites away. Where the n allows it (860 pairs in the scan) it is the better test; where it does not (47 donor pairs in the transplant) the covariate adjustment uses every site and is the one to quote.</a:t>
             </a:r>
             <a:endParaRPr lang="en-US" dirty="0"/>
           </a:p>
@@ -1442,8 +1452,8 @@
           <a:p>
             <a:r>
               <a:rPr lang="en-US" dirty="0"/>
-              <a:t>If the flank question comes up: the MPRA destroys the flanks of a 170 bp fragment on a plasmid and reads transcription; we move an intact ~0.8 kb element into closed chromatin and read accessibility. There is no chromatin to open in the MPRA. The honest shared conclusion is that neither assay finds much class information in 170 bp.
-Everything here is predicted accessibility from a model fine-tuned on our own fibroblast ATAC, not a measurement, and not the MPRA-trained probe used in the manuscript.</a:t>
+              <a:t>From the fibroblast titration, 2,359 sites, 860 accessibility-matched pairs (caliper 0.1 log10). This slide is the argument for why the matched analysis is worth doing - two of the five largest raw class differences in the titration were entirely explained by the accessibility gap.
+Age Down is the outlier again, consistently with the other arms: one base of the core changed -0.62 vs Stable -0.83; motif gone -0.72 vs -1.07.</a:t>
             </a:r>
             <a:endParaRPr lang="en-US" dirty="0"/>
           </a:p>
@@ -1579,6 +1589,95 @@
 </p:notes>
 </file>
 
+<file path=ppt/notesSlides/notesSlide20.xml><?xml version="1.0" encoding="utf-8"?>
+<p:notes xmlns:a="http://schemas.openxmlformats.org/drawingml/2006/main" xmlns:r="http://schemas.openxmlformats.org/officeDocument/2006/relationships" xmlns:p="http://schemas.openxmlformats.org/presentationml/2006/main">
+  <p:cSld>
+    <p:spTree>
+      <p:nvGrpSpPr>
+        <p:cNvPr id="1" name=""/>
+        <p:cNvGrpSpPr/>
+        <p:nvPr/>
+      </p:nvGrpSpPr>
+      <p:grpSpPr>
+        <a:xfrm>
+          <a:off x="0" y="0"/>
+          <a:ext cx="0" cy="0"/>
+          <a:chOff x="0" y="0"/>
+          <a:chExt cx="0" cy="0"/>
+        </a:xfrm>
+      </p:grpSpPr>
+      <p:sp>
+        <p:nvSpPr>
+          <p:cNvPr id="2" name="Slide Image Placeholder 1"/>
+          <p:cNvSpPr>
+            <a:spLocks noGrp="1" noRot="1" noChangeAspect="1"/>
+          </p:cNvSpPr>
+          <p:nvPr>
+            <p:ph type="sldImg"/>
+          </p:nvPr>
+        </p:nvSpPr>
+        <p:spPr/>
+      </p:sp>
+      <p:sp>
+        <p:nvSpPr>
+          <p:cNvPr id="3" name="Notes Placeholder 2"/>
+          <p:cNvSpPr>
+            <a:spLocks noGrp="1"/>
+          </p:cNvSpPr>
+          <p:nvPr>
+            <p:ph type="body" idx="1"/>
+          </p:nvPr>
+        </p:nvSpPr>
+        <p:spPr/>
+        <p:txBody>
+          <a:bodyPr/>
+          <a:lstStyle/>
+          <a:p>
+            <a:r>
+              <a:rPr lang="en-US" dirty="0"/>
+              <a:t>If the flank question comes up: the MPRA destroys the flanks of a 170 bp fragment on a plasmid and reads transcription; we move an intact ~0.8 kb element into closed chromatin and read accessibility. There is no chromatin to open in the MPRA. The honest shared conclusion is that neither assay finds much class information in 170 bp.
+Everything here is predicted accessibility from a model fine-tuned on our own fibroblast ATAC, not a measurement, and not the MPRA-trained probe used in the manuscript.</a:t>
+            </a:r>
+            <a:endParaRPr lang="en-US" dirty="0"/>
+          </a:p>
+        </p:txBody>
+      </p:sp>
+      <p:sp>
+        <p:nvSpPr>
+          <p:cNvPr id="4" name="Slide Number Placeholder 3"/>
+          <p:cNvSpPr>
+            <a:spLocks noGrp="1"/>
+          </p:cNvSpPr>
+          <p:nvPr>
+            <p:ph type="sldNum" sz="quarter" idx="10"/>
+          </p:nvPr>
+        </p:nvSpPr>
+        <p:spPr/>
+        <p:txBody>
+          <a:bodyPr/>
+          <a:lstStyle/>
+          <a:p>
+            <a:fld id="{F7021451-1387-4CA6-816F-3879F97B5CBC}" type="slidenum">
+              <a:rPr lang="en-US"/>
+              <a:t>20</a:t>
+            </a:fld>
+            <a:endParaRPr lang="en-US"/>
+          </a:p>
+        </p:txBody>
+      </p:sp>
+    </p:spTree>
+    <p:extLst>
+      <p:ext uri="{BB962C8B-B14F-4D97-AF65-F5344CB8AC3E}">
+        <p14:creationId xmlns:p14="http://schemas.microsoft.com/office/powerpoint/2010/main" val="1024086991"/>
+      </p:ext>
+    </p:extLst>
+  </p:cSld>
+  <p:clrMapOvr>
+    <a:masterClrMapping/>
+  </p:clrMapOvr>
+</p:notes>
+</file>
+
 <file path=ppt/notesSlides/notesSlide3.xml><?xml version="1.0" encoding="utf-8"?>
 <p:notes xmlns:a="http://schemas.openxmlformats.org/drawingml/2006/main" xmlns:r="http://schemas.openxmlformats.org/officeDocument/2006/relationships" xmlns:p="http://schemas.openxmlformats.org/presentationml/2006/main">
   <p:cSld>
@@ -2184,7 +2283,7 @@
               <a:rPr lang="en-US" dirty="0"/>
               <a:t>2,340 sites. Own AP-1 motif, median log2, with BH-adjusted P against Stable:
   Stable -1.21 (n=1179, reference) · Age Up -1.19 (n=605, FDR 0.93) · Age Down -0.78 (n=209, FDR 9.1e-5) · Exercise Up -1.14 (n=233, FDR 0.49) · Exercise Down -0.96 (n=114, FDR 0.043)
-Partner motifs, net of control: -0.20 / -0.25 / -0.22 / -0.23 / -0.33. Nothing survives BH (smallest adjusted 0.20), so the deficit is AP-1-specific in both losing classes. So the deficit is AP-1-specific, not general weakness. No single partner family takes over: nothing survives FDR in the per-family split.
+Partner motifs, net of control: -0.20 / -0.25 / -0.22 / -0.23 / -0.33. Nothing survives BH (smallest adjusted 0.20), Split by FAMILY rather than pooled there is a backup slide: the same three families lead everywhere (C/EBP, NFI, E-box bHLH), and three isolated class differences appear, the solid one being heat-shock motifs in Exercise Down. That is a finer and far more multiply-tested question; it does not contradict the null here. so the deficit is AP-1-specific in both losing classes. So the deficit is AP-1-specific, not general weakness. No single partner family takes over: nothing survives FDR in the per-family split.
 Agreement: pooled Stable vs Dynamic at the motif is a null, which matches the manuscript's core-scramble result (no class difference). Age-gained being on par with Stable is the sequence-level version of 'age-gained reporter activity on par with stable'.
 Note on the split: a site that is dynamic with both age and exercise is counted under its age class, so the two exercise groups are the sites that are NOT also age-dynamic. Splitting them is what separated the old 'other Dynamic' group (p = 0.055, n = 347) into Exercise Up, which looks like Stable, and Exercise Down, which does not.
 Caveat: the own-AP-1 bar has no matched control, because one at distance 0 would overlap the motif. That inflates AP-1 relative to the partners in every class equally, so the class comparison is unaffected.</a:t>
@@ -8863,7 +8962,7 @@
                   <a:schemeClr val="tx1"/>
                 </a:solidFill>
               </a:rPr>
-              <a:t>Is it just that Dynamic sites are less accessible?</a:t>
+              <a:t>Besides AP-1, which partners do the sites lean on?</a:t>
             </a:r>
             <a:endParaRPr lang="en-US" sz="2800" dirty="0"/>
           </a:p>
@@ -8908,7 +9007,7 @@
                   <a:srgbClr val="111111"/>
                 </a:solidFill>
               </a:rPr>
-              <a:t>Immune by design — both numbers come from the same window of the same site, so accessibility cancels</a:t>
+              <a:t>The same three lead in every class — only how hard they are leaned on changes</a:t>
             </a:r>
             <a:endParaRPr lang="en-US" sz="1700" dirty="0"/>
           </a:p>
@@ -8926,7 +9025,25 @@
                   <a:srgbClr val="595959"/>
                 </a:solidFill>
               </a:rPr>
-              <a:t>Motif specificity · partner share. Partners are also net of a width- and distance-matched footprint-free control at the mirrored distance. No between-class matching needed, and none done.</a:t>
+              <a:t>Stable sites: C/EBP −0.69 (in 11% of them) · NFI −0.36 (28%) · E-box bHLH −0.27 (49%) · heat shock −0.19 (33%) · TEAD −0.16 (15%). Net log2 after subtracting a width- and distance-matched footprint-free control.</a:t>
+            </a:r>
+            <a:endParaRPr lang="en-US" sz="1700" dirty="0"/>
+          </a:p>
+          <a:p>
+            <a:pPr algn="l" lvl="1" marL="685800" indent="-342900">
+              <a:spcAft>
+                <a:spcPts val="400"/>
+              </a:spcAft>
+              <a:buSzPct val="100000"/>
+              <a:buChar char="▪"/>
+            </a:pPr>
+            <a:r>
+              <a:rPr lang="en-US" sz="1450" dirty="0">
+                <a:solidFill>
+                  <a:srgbClr val="595959"/>
+                </a:solidFill>
+              </a:rPr>
+              <a:t>C/EBP hits hardest where it is present; E-box bHLH is the one most sites actually carry.</a:t>
             </a:r>
             <a:endParaRPr lang="en-US" sz="1700" dirty="0"/>
           </a:p>
@@ -8947,7 +9064,7 @@
                   <a:srgbClr val="111111"/>
                 </a:solidFill>
               </a:rPr>
-              <a:t>Accessibility is in the model, not matched out</a:t>
+              <a:t>Three class differences clear BH, and only one of them convincingly</a:t>
             </a:r>
             <a:endParaRPr lang="en-US" sz="1700" dirty="0"/>
           </a:p>
@@ -8965,7 +9082,25 @@
                   <a:srgbClr val="595959"/>
                 </a:solidFill>
               </a:rPr>
-              <a:t>The swap: each class's regression conditions on both the donor's and the recipient's own native level, so the carried share is already net of the gap.</a:t>
+              <a:t>Exercise Down leans far harder on heat-shock / stress motifs: −0.69 against Stable's −0.19, FDR 0.005.</a:t>
+            </a:r>
+            <a:endParaRPr lang="en-US" sz="1700" dirty="0"/>
+          </a:p>
+          <a:p>
+            <a:pPr algn="l" lvl="1" marL="685800" indent="-342900">
+              <a:spcAft>
+                <a:spcPts val="400"/>
+              </a:spcAft>
+              <a:buSzPct val="100000"/>
+              <a:buChar char="▪"/>
+            </a:pPr>
+            <a:r>
+              <a:rPr lang="en-US" sz="1450" dirty="0">
+                <a:solidFill>
+                  <a:srgbClr val="595959"/>
+                </a:solidFill>
+              </a:rPr>
+              <a:t>Age Up leans harder on NFI (−0.89 against −0.36) and on KLF/SP, both FDR 0.045 — but see the caveat.</a:t>
             </a:r>
             <a:endParaRPr lang="en-US" sz="1700" dirty="0"/>
           </a:p>
@@ -8986,7 +9121,7 @@
                   <a:srgbClr val="111111"/>
                 </a:solidFill>
               </a:rPr>
-              <a:t>Matched explicitly, and survived</a:t>
+              <a:t>Read these as leads, not findings</a:t>
             </a:r>
             <a:endParaRPr lang="en-US" sz="1700" dirty="0"/>
           </a:p>
@@ -9004,28 +9139,7 @@
                   <a:srgbClr val="595959"/>
                 </a:solidFill>
               </a:rPr>
-              <a:t>Importance density: 33.8% vs 30.7% unmatched, and 33.1% vs 31.3% over 860 pairs matched on predicted accessibility (caliper 0.1 log10), +1.5 points, P = 0.006.</a:t>
-            </a:r>
-            <a:endParaRPr lang="en-US" sz="1700" dirty="0"/>
-          </a:p>
-          <a:p>
-            <a:pPr algn="l" marL="342900" indent="-342900">
-              <a:spcBef>
-                <a:spcPts val="1100"/>
-              </a:spcBef>
-              <a:spcAft>
-                <a:spcPts val="300"/>
-              </a:spcAft>
-              <a:buSzPct val="100000"/>
-              <a:buChar char="•"/>
-            </a:pPr>
-            <a:r>
-              <a:rPr lang="en-US" sz="1700" b="1" dirty="0">
-                <a:solidFill>
-                  <a:srgbClr val="111111"/>
-                </a:solidFill>
-              </a:rPr>
-              <a:t>Checked, and only survives as a covariate adjustment</a:t>
+              <a:t>BH is applied within each class. Across all four Dynamic classes and every family together, only the heat-shock result would survive; the two at 0.045 would not.</a:t>
             </a:r>
             <a:endParaRPr lang="en-US" sz="1700" dirty="0"/>
           </a:p>
@@ -9043,28 +9157,7 @@
                   <a:srgbClr val="595959"/>
                 </a:solidFill>
               </a:rPr>
-              <a:t>Transplant: every element goes into the same 20 hosts, so the host cancels — but the donor classes are not matched. 1:1 matching leaves only 47 pairs and is not significant (P = 0.13). The covariate-adjusted gap is: +0.84 ± 0.30 log2, about 1.8x, P = 0.005. Quote that one.</a:t>
-            </a:r>
-            <a:endParaRPr lang="en-US" sz="1700" dirty="0"/>
-          </a:p>
-          <a:p>
-            <a:pPr algn="l" marL="342900" indent="-342900">
-              <a:spcBef>
-                <a:spcPts val="1100"/>
-              </a:spcBef>
-              <a:spcAft>
-                <a:spcPts val="300"/>
-              </a:spcAft>
-              <a:buSzPct val="100000"/>
-              <a:buChar char="•"/>
-            </a:pPr>
-            <a:r>
-              <a:rPr lang="en-US" sz="1700" b="1" dirty="0">
-                <a:solidFill>
-                  <a:srgbClr val="111111"/>
-                </a:solidFill>
-              </a:rPr>
-              <a:t>Checked, and did not survive</a:t>
+              <a:t>Footprint detection needs signal, so a less accessible class yields fewer called partners — the share column moves with accessibility even where the net effect does not.</a:t>
             </a:r>
             <a:endParaRPr lang="en-US" sz="1700" dirty="0"/>
           </a:p>
@@ -9082,7 +9175,7 @@
                   <a:srgbClr val="595959"/>
                 </a:solidFill>
               </a:rPr>
-              <a:t>Top tile is a core tile: 56% vs 52% raw, matched McNemar P = 0.21 — reported as a shared fact, not a class difference. Plus the two titration results on the next slide.</a:t>
+              <a:t>This is the partner shuffle, not the scan. A tile or sliding scan says which 10 bp matter, never what is written there.</a:t>
             </a:r>
             <a:endParaRPr lang="en-US" sz="1700" dirty="0"/>
           </a:p>
@@ -9190,7 +9283,7 @@
                   <a:schemeClr val="tx1"/>
                 </a:solidFill>
               </a:rPr>
-              <a:t>Two differences that turned out to be accessibility</a:t>
+              <a:t>Is it just that Dynamic sites are less accessible?</a:t>
             </a:r>
             <a:endParaRPr lang="en-US" sz="2800" dirty="0"/>
           </a:p>
@@ -9235,7 +9328,7 @@
                   <a:srgbClr val="111111"/>
                 </a:solidFill>
               </a:rPr>
-              <a:t>A second AP-1 copy looked worth more to Dynamic sites</a:t>
+              <a:t>Immune by design — both numbers come from the same window of the same site, so accessibility cancels</a:t>
             </a:r>
             <a:endParaRPr lang="en-US" sz="1700" dirty="0"/>
           </a:p>
@@ -9253,7 +9346,7 @@
                   <a:srgbClr val="595959"/>
                 </a:solidFill>
               </a:rPr>
-              <a:t>+0.72 vs +0.60 log2, p &lt; 1e-4 — matched on accessibility, p = 0.93. Gone.</a:t>
+              <a:t>Motif specificity · partner share. Partners are also net of a width- and distance-matched footprint-free control at the mirrored distance. No between-class matching needed, and none done.</a:t>
             </a:r>
             <a:endParaRPr lang="en-US" sz="1700" dirty="0"/>
           </a:p>
@@ -9274,7 +9367,7 @@
                   <a:srgbClr val="111111"/>
                 </a:solidFill>
               </a:rPr>
-              <a:t>Upgrading an imperfect core to a perfect TGAGTCA looked worth more to Dynamic sites</a:t>
+              <a:t>Accessibility is in the model, not matched out</a:t>
             </a:r>
             <a:endParaRPr lang="en-US" sz="1700" dirty="0"/>
           </a:p>
@@ -9292,7 +9385,7 @@
                   <a:srgbClr val="595959"/>
                 </a:solidFill>
               </a:rPr>
-              <a:t>+0.66 vs +0.52, p &lt; 1e-4 — matched, p = 0.94. Gone.</a:t>
+              <a:t>The swap: each class's regression conditions on both the donor's and the recipient's own native level, so the carried share is already net of the gap.</a:t>
             </a:r>
             <a:endParaRPr lang="en-US" sz="1700" dirty="0"/>
           </a:p>
@@ -9313,7 +9406,7 @@
                   <a:srgbClr val="111111"/>
                 </a:solidFill>
               </a:rPr>
-              <a:t>What did survive matching</a:t>
+              <a:t>Matched explicitly, and survived</a:t>
             </a:r>
             <a:endParaRPr lang="en-US" sz="1700" dirty="0"/>
           </a:p>
@@ -9331,7 +9424,7 @@
                   <a:srgbClr val="595959"/>
                 </a:solidFill>
               </a:rPr>
-              <a:t>Destroying the motif costs Dynamic sites less (+0.16, p = 4e-4); the dose-response is shallower; relocating the motif helps them less.</a:t>
+              <a:t>Importance density: 33.8% vs 30.7% unmatched, and 33.1% vs 31.3% over 860 pairs matched on predicted accessibility (caliper 0.1 log10), +1.5 points, P = 0.006.</a:t>
             </a:r>
             <a:endParaRPr lang="en-US" sz="1700" dirty="0"/>
           </a:p>
@@ -9352,7 +9445,7 @@
                   <a:srgbClr val="111111"/>
                 </a:solidFill>
               </a:rPr>
-              <a:t>Two clean negatives worth having</a:t>
+              <a:t>Checked, and only survives as a covariate adjustment</a:t>
             </a:r>
             <a:endParaRPr lang="en-US" sz="1700" dirty="0"/>
           </a:p>
@@ -9370,7 +9463,28 @@
                   <a:srgbClr val="595959"/>
                 </a:solidFill>
               </a:rPr>
-              <a:t>Reverse-complementing the whole motif costs nothing in either class (-0.03 log2, p = 0.89) — expected for a palindromic TRE, and a sanity check on the head.</a:t>
+              <a:t>Transplant: every element goes into the same 20 hosts, so the host cancels — but the donor classes are not matched. 1:1 matching leaves only 47 pairs and is not significant (P = 0.13). The covariate-adjusted gap is: +0.84 ± 0.30 log2, about 1.8x, P = 0.005. Quote that one.</a:t>
+            </a:r>
+            <a:endParaRPr lang="en-US" sz="1700" dirty="0"/>
+          </a:p>
+          <a:p>
+            <a:pPr algn="l" marL="342900" indent="-342900">
+              <a:spcBef>
+                <a:spcPts val="1100"/>
+              </a:spcBef>
+              <a:spcAft>
+                <a:spcPts val="300"/>
+              </a:spcAft>
+              <a:buSzPct val="100000"/>
+              <a:buChar char="•"/>
+            </a:pPr>
+            <a:r>
+              <a:rPr lang="en-US" sz="1700" b="1" dirty="0">
+                <a:solidFill>
+                  <a:srgbClr val="111111"/>
+                </a:solidFill>
+              </a:rPr>
+              <a:t>Checked, and did not survive</a:t>
             </a:r>
             <a:endParaRPr lang="en-US" sz="1700" dirty="0"/>
           </a:p>
@@ -9388,7 +9502,7 @@
                   <a:srgbClr val="595959"/>
                 </a:solidFill>
               </a:rPr>
-              <a:t>The spacing preference for a second copy is identical: best at ±20–40 bp, decaying by ±150 bp, with no class difference at any distance (all FDR &gt; 0.58).</a:t>
+              <a:t>Top tile is a core tile: 56% vs 52% raw, matched McNemar P = 0.21 — reported as a shared fact, not a class difference. Plus the two titration results on the next slide.</a:t>
             </a:r>
             <a:endParaRPr lang="en-US" sz="1700" dirty="0"/>
           </a:p>
@@ -9496,7 +9610,7 @@
                   <a:schemeClr val="tx1"/>
                 </a:solidFill>
               </a:rPr>
-              <a:t>How this sits with the MPRA work</a:t>
+              <a:t>Two differences that turned out to be accessibility</a:t>
             </a:r>
             <a:endParaRPr lang="en-US" sz="2800" dirty="0"/>
           </a:p>
@@ -9541,7 +9655,7 @@
                   <a:srgbClr val="111111"/>
                 </a:solidFill>
               </a:rPr>
-              <a:t>Agrees</a:t>
+              <a:t>A second AP-1 copy looked worth more to Dynamic sites</a:t>
             </a:r>
             <a:endParaRPr lang="en-US" sz="1700" dirty="0"/>
           </a:p>
@@ -9559,61 +9673,7 @@
                   <a:srgbClr val="595959"/>
                 </a:solidFill>
               </a:rPr>
-              <a:t>Dynamic elements have weaker endogenous chromatin, and depend on context rather than being sequence-autonomous.</a:t>
-            </a:r>
-            <a:endParaRPr lang="en-US" sz="1700" dirty="0"/>
-          </a:p>
-          <a:p>
-            <a:pPr algn="l" lvl="1" marL="685800" indent="-342900">
-              <a:spcAft>
-                <a:spcPts val="400"/>
-              </a:spcAft>
-              <a:buSzPct val="100000"/>
-              <a:buChar char="▪"/>
-            </a:pPr>
-            <a:r>
-              <a:rPr lang="en-US" sz="1450" dirty="0">
-                <a:solidFill>
-                  <a:srgbClr val="595959"/>
-                </a:solidFill>
-              </a:rPr>
-              <a:t>Shuffling the AP-1 core alone does not separate pooled Stable from pooled Dynamic.</a:t>
-            </a:r>
-            <a:endParaRPr lang="en-US" sz="1700" dirty="0"/>
-          </a:p>
-          <a:p>
-            <a:pPr algn="l" lvl="1" marL="685800" indent="-342900">
-              <a:spcAft>
-                <a:spcPts val="400"/>
-              </a:spcAft>
-              <a:buSzPct val="100000"/>
-              <a:buChar char="▪"/>
-            </a:pPr>
-            <a:r>
-              <a:rPr lang="en-US" sz="1450" dirty="0">
-                <a:solidFill>
-                  <a:srgbClr val="595959"/>
-                </a:solidFill>
-              </a:rPr>
-              <a:t>Age-gained elements behave like Stable ones — here, at their own AP-1 motif.</a:t>
-            </a:r>
-            <a:endParaRPr lang="en-US" sz="1700" dirty="0"/>
-          </a:p>
-          <a:p>
-            <a:pPr algn="l" lvl="1" marL="685800" indent="-342900">
-              <a:spcAft>
-                <a:spcPts val="400"/>
-              </a:spcAft>
-              <a:buSzPct val="100000"/>
-              <a:buChar char="▪"/>
-            </a:pPr>
-            <a:r>
-              <a:rPr lang="en-US" sz="1450" dirty="0">
-                <a:solidFill>
-                  <a:srgbClr val="595959"/>
-                </a:solidFill>
-              </a:rPr>
-              <a:t>C/EBP is the strongest partner motif at fibroblast AP-1 sites (net −0.71 log2, ahead of MEF2 and NFI).</a:t>
+              <a:t>+0.72 vs +0.60 log2, p &lt; 1e-4 — matched on accessibility, p = 0.93. Gone.</a:t>
             </a:r>
             <a:endParaRPr lang="en-US" sz="1700" dirty="0"/>
           </a:p>
@@ -9634,7 +9694,7 @@
                   <a:srgbClr val="111111"/>
                 </a:solidFill>
               </a:rPr>
-              <a:t>Adds</a:t>
+              <a:t>Upgrading an imperfect core to a perfect TGAGTCA looked worth more to Dynamic sites</a:t>
             </a:r>
             <a:endParaRPr lang="en-US" sz="1700" dirty="0"/>
           </a:p>
@@ -9652,61 +9712,7 @@
                   <a:srgbClr val="595959"/>
                 </a:solidFill>
               </a:rPr>
-              <a:t>The class difference is a whole-peak property, not a 170 bp one.</a:t>
-            </a:r>
-            <a:endParaRPr lang="en-US" sz="1700" dirty="0"/>
-          </a:p>
-          <a:p>
-            <a:pPr algn="l" lvl="1" marL="685800" indent="-342900">
-              <a:spcAft>
-                <a:spcPts val="400"/>
-              </a:spcAft>
-              <a:buSzPct val="100000"/>
-              <a:buChar char="▪"/>
-            </a:pPr>
-            <a:r>
-              <a:rPr lang="en-US" sz="1450" dirty="0">
-                <a:solidFill>
-                  <a:srgbClr val="595959"/>
-                </a:solidFill>
-              </a:rPr>
-              <a:t>Within Dynamic, the AP-1-LOSING sites are the ones that are sequence-different, with age and with exercise alike; the gaining ones look like Stable. Direction, not stimulus.</a:t>
-            </a:r>
-            <a:endParaRPr lang="en-US" sz="1700" dirty="0"/>
-          </a:p>
-          <a:p>
-            <a:pPr algn="l" lvl="1" marL="685800" indent="-342900">
-              <a:spcAft>
-                <a:spcPts val="400"/>
-              </a:spcAft>
-              <a:buSzPct val="100000"/>
-              <a:buChar char="▪"/>
-            </a:pPr>
-            <a:r>
-              <a:rPr lang="en-US" sz="1450" dirty="0">
-                <a:solidFill>
-                  <a:srgbClr val="595959"/>
-                </a:solidFill>
-              </a:rPr>
-              <a:t>Unprompted, AlphaGenome makes the AP-1 core the most important 10 bp in over half of all sites — equally in both classes. The classes differ in how much of the dependence sits there, not in whether AP-1 leads.</a:t>
-            </a:r>
-            <a:endParaRPr lang="en-US" sz="1700" dirty="0"/>
-          </a:p>
-          <a:p>
-            <a:pPr algn="l" lvl="1" marL="685800" indent="-342900">
-              <a:spcAft>
-                <a:spcPts val="400"/>
-              </a:spcAft>
-              <a:buSzPct val="100000"/>
-              <a:buChar char="▪"/>
-            </a:pPr>
-            <a:r>
-              <a:rPr lang="en-US" sz="1450" dirty="0">
-                <a:solidFill>
-                  <a:srgbClr val="595959"/>
-                </a:solidFill>
-              </a:rPr>
-              <a:t>Dynamic sites spread their dependence slightly wider, and it survives accessibility matching (33.1% vs 31.3% within ±25 bp, P = 0.006) — the sequence-model version of “attention is more distributed at dynamic enhancers”.</a:t>
+              <a:t>+0.66 vs +0.52, p &lt; 1e-4 — matched, p = 0.94. Gone.</a:t>
             </a:r>
             <a:endParaRPr lang="en-US" sz="1700" dirty="0"/>
           </a:p>
@@ -9727,7 +9733,7 @@
                   <a:srgbClr val="111111"/>
                 </a:solidFill>
               </a:rPr>
-              <a:t>Keep off the slides</a:t>
+              <a:t>What did survive matching</a:t>
             </a:r>
             <a:endParaRPr lang="en-US" sz="1700" dirty="0"/>
           </a:p>
@@ -9745,7 +9751,64 @@
                   <a:srgbClr val="595959"/>
                 </a:solidFill>
               </a:rPr>
-              <a:t>Our in-situ 170 bp shuffle costs Stable sites more (−2.51 vs −1.96, p = 4e-40), the opposite of the MPRA flank result. Different assay — episomal activity vs chromatin accessibility — but it reads as a contradiction.</a:t>
+              <a:t>Destroying the motif costs Dynamic sites less (+0.16, p = 4e-4); the dose-response is shallower; relocating the motif helps them less.</a:t>
+            </a:r>
+            <a:endParaRPr lang="en-US" sz="1700" dirty="0"/>
+          </a:p>
+          <a:p>
+            <a:pPr algn="l" marL="342900" indent="-342900">
+              <a:spcBef>
+                <a:spcPts val="1100"/>
+              </a:spcBef>
+              <a:spcAft>
+                <a:spcPts val="300"/>
+              </a:spcAft>
+              <a:buSzPct val="100000"/>
+              <a:buChar char="•"/>
+            </a:pPr>
+            <a:r>
+              <a:rPr lang="en-US" sz="1700" b="1" dirty="0">
+                <a:solidFill>
+                  <a:srgbClr val="111111"/>
+                </a:solidFill>
+              </a:rPr>
+              <a:t>Two clean negatives worth having</a:t>
+            </a:r>
+            <a:endParaRPr lang="en-US" sz="1700" dirty="0"/>
+          </a:p>
+          <a:p>
+            <a:pPr algn="l" lvl="1" marL="685800" indent="-342900">
+              <a:spcAft>
+                <a:spcPts val="400"/>
+              </a:spcAft>
+              <a:buSzPct val="100000"/>
+              <a:buChar char="▪"/>
+            </a:pPr>
+            <a:r>
+              <a:rPr lang="en-US" sz="1450" dirty="0">
+                <a:solidFill>
+                  <a:srgbClr val="595959"/>
+                </a:solidFill>
+              </a:rPr>
+              <a:t>Reverse-complementing the whole motif costs nothing in either class (-0.03 log2, p = 0.89) — expected for a palindromic TRE, and a sanity check on the head.</a:t>
+            </a:r>
+            <a:endParaRPr lang="en-US" sz="1700" dirty="0"/>
+          </a:p>
+          <a:p>
+            <a:pPr algn="l" lvl="1" marL="685800" indent="-342900">
+              <a:spcAft>
+                <a:spcPts val="400"/>
+              </a:spcAft>
+              <a:buSzPct val="100000"/>
+              <a:buChar char="▪"/>
+            </a:pPr>
+            <a:r>
+              <a:rPr lang="en-US" sz="1450" dirty="0">
+                <a:solidFill>
+                  <a:srgbClr val="595959"/>
+                </a:solidFill>
+              </a:rPr>
+              <a:t>The spacing preference for a second copy is identical: best at ±20–40 bp, decaying by ±150 bp, with no class difference at any distance (all FDR &gt; 0.58).</a:t>
             </a:r>
             <a:endParaRPr lang="en-US" sz="1700" dirty="0"/>
           </a:p>
@@ -13065,6 +13128,363 @@
             <a:fld id="{F7021451-1387-4CA6-816F-3879F97B5CBC}" type="slidenum">
               <a:rPr b="0" lang="en-US"/>
               <a:t>2</a:t>
+            </a:fld>
+            <a:endParaRPr lang="en-US"/>
+          </a:p>
+        </p:txBody>
+      </p:sp>
+    </p:spTree>
+  </p:cSld>
+  <p:clrMapOvr>
+    <a:masterClrMapping/>
+  </p:clrMapOvr>
+</p:sld>
+</file>
+
+<file path=ppt/slides/slide20.xml><?xml version="1.0" encoding="utf-8"?>
+<p:sld xmlns:a="http://schemas.openxmlformats.org/drawingml/2006/main" xmlns:r="http://schemas.openxmlformats.org/officeDocument/2006/relationships" xmlns:p="http://schemas.openxmlformats.org/presentationml/2006/main">
+  <p:cSld name="Slide 20">
+    <p:spTree>
+      <p:nvGrpSpPr>
+        <p:cNvPr id="1" name=""/>
+        <p:cNvGrpSpPr/>
+        <p:nvPr/>
+      </p:nvGrpSpPr>
+      <p:grpSpPr>
+        <a:xfrm>
+          <a:off x="0" y="0"/>
+          <a:ext cx="0" cy="0"/>
+          <a:chOff x="0" y="0"/>
+          <a:chExt cx="0" cy="0"/>
+        </a:xfrm>
+      </p:grpSpPr>
+      <p:sp>
+        <p:nvSpPr>
+          <p:cNvPr id="2" name="Text 0"/>
+          <p:cNvSpPr/>
+          <p:nvPr>
+            <p:ph idx="100" type="title" hasCustomPrompt="1"/>
+          </p:nvPr>
+        </p:nvSpPr>
+        <p:spPr>
+          <a:xfrm>
+            <a:off x="502920" y="274320"/>
+            <a:ext cx="11155680" cy="731520"/>
+          </a:xfrm>
+          <a:prstGeom prst="rect">
+            <a:avLst/>
+          </a:prstGeom>
+          <a:noFill/>
+          <a:ln/>
+        </p:spPr>
+        <p:txBody>
+          <a:bodyPr wrap="square" rtlCol="0" anchor="ctr"/>
+          <a:lstStyle/>
+          <a:p>
+            <a:pPr algn="l" indent="0" marL="0">
+              <a:buNone/>
+            </a:pPr>
+            <a:r>
+              <a:rPr lang="en-US" sz="2800" b="1" dirty="0">
+                <a:solidFill>
+                  <a:schemeClr val="tx1"/>
+                </a:solidFill>
+              </a:rPr>
+              <a:t>How this sits with the MPRA work</a:t>
+            </a:r>
+            <a:endParaRPr lang="en-US" sz="2800" dirty="0"/>
+          </a:p>
+        </p:txBody>
+      </p:sp>
+      <p:sp>
+        <p:nvSpPr>
+          <p:cNvPr id="3" name="Text 0"/>
+          <p:cNvSpPr/>
+          <p:nvPr>
+            <p:ph idx="101" type="body" hasCustomPrompt="1"/>
+          </p:nvPr>
+        </p:nvSpPr>
+        <p:spPr>
+          <a:xfrm>
+            <a:off x="502920" y="1234440"/>
+            <a:ext cx="11155680" cy="5029200"/>
+          </a:xfrm>
+          <a:prstGeom prst="rect">
+            <a:avLst/>
+          </a:prstGeom>
+          <a:noFill/>
+          <a:ln/>
+        </p:spPr>
+        <p:txBody>
+          <a:bodyPr wrap="square" rtlCol="0" anchor="t"/>
+          <a:lstStyle/>
+          <a:p>
+            <a:pPr algn="l" marL="342900" indent="-342900">
+              <a:spcBef>
+                <a:spcPts val="1100"/>
+              </a:spcBef>
+              <a:spcAft>
+                <a:spcPts val="300"/>
+              </a:spcAft>
+              <a:buSzPct val="100000"/>
+              <a:buChar char="•"/>
+            </a:pPr>
+            <a:r>
+              <a:rPr lang="en-US" sz="1700" b="1" dirty="0">
+                <a:solidFill>
+                  <a:srgbClr val="111111"/>
+                </a:solidFill>
+              </a:rPr>
+              <a:t>Agrees</a:t>
+            </a:r>
+            <a:endParaRPr lang="en-US" sz="1700" dirty="0"/>
+          </a:p>
+          <a:p>
+            <a:pPr algn="l" lvl="1" marL="685800" indent="-342900">
+              <a:spcAft>
+                <a:spcPts val="400"/>
+              </a:spcAft>
+              <a:buSzPct val="100000"/>
+              <a:buChar char="▪"/>
+            </a:pPr>
+            <a:r>
+              <a:rPr lang="en-US" sz="1450" dirty="0">
+                <a:solidFill>
+                  <a:srgbClr val="595959"/>
+                </a:solidFill>
+              </a:rPr>
+              <a:t>Dynamic elements have weaker endogenous chromatin, and depend on context rather than being sequence-autonomous.</a:t>
+            </a:r>
+            <a:endParaRPr lang="en-US" sz="1700" dirty="0"/>
+          </a:p>
+          <a:p>
+            <a:pPr algn="l" lvl="1" marL="685800" indent="-342900">
+              <a:spcAft>
+                <a:spcPts val="400"/>
+              </a:spcAft>
+              <a:buSzPct val="100000"/>
+              <a:buChar char="▪"/>
+            </a:pPr>
+            <a:r>
+              <a:rPr lang="en-US" sz="1450" dirty="0">
+                <a:solidFill>
+                  <a:srgbClr val="595959"/>
+                </a:solidFill>
+              </a:rPr>
+              <a:t>Shuffling the AP-1 core alone does not separate pooled Stable from pooled Dynamic.</a:t>
+            </a:r>
+            <a:endParaRPr lang="en-US" sz="1700" dirty="0"/>
+          </a:p>
+          <a:p>
+            <a:pPr algn="l" lvl="1" marL="685800" indent="-342900">
+              <a:spcAft>
+                <a:spcPts val="400"/>
+              </a:spcAft>
+              <a:buSzPct val="100000"/>
+              <a:buChar char="▪"/>
+            </a:pPr>
+            <a:r>
+              <a:rPr lang="en-US" sz="1450" dirty="0">
+                <a:solidFill>
+                  <a:srgbClr val="595959"/>
+                </a:solidFill>
+              </a:rPr>
+              <a:t>Age-gained elements behave like Stable ones — here, at their own AP-1 motif.</a:t>
+            </a:r>
+            <a:endParaRPr lang="en-US" sz="1700" dirty="0"/>
+          </a:p>
+          <a:p>
+            <a:pPr algn="l" lvl="1" marL="685800" indent="-342900">
+              <a:spcAft>
+                <a:spcPts val="400"/>
+              </a:spcAft>
+              <a:buSzPct val="100000"/>
+              <a:buChar char="▪"/>
+            </a:pPr>
+            <a:r>
+              <a:rPr lang="en-US" sz="1450" dirty="0">
+                <a:solidFill>
+                  <a:srgbClr val="595959"/>
+                </a:solidFill>
+              </a:rPr>
+              <a:t>C/EBP is the strongest partner motif at fibroblast AP-1 sites (net −0.71 log2, ahead of MEF2 and NFI).</a:t>
+            </a:r>
+            <a:endParaRPr lang="en-US" sz="1700" dirty="0"/>
+          </a:p>
+          <a:p>
+            <a:pPr algn="l" marL="342900" indent="-342900">
+              <a:spcBef>
+                <a:spcPts val="1100"/>
+              </a:spcBef>
+              <a:spcAft>
+                <a:spcPts val="300"/>
+              </a:spcAft>
+              <a:buSzPct val="100000"/>
+              <a:buChar char="•"/>
+            </a:pPr>
+            <a:r>
+              <a:rPr lang="en-US" sz="1700" b="1" dirty="0">
+                <a:solidFill>
+                  <a:srgbClr val="111111"/>
+                </a:solidFill>
+              </a:rPr>
+              <a:t>Adds</a:t>
+            </a:r>
+            <a:endParaRPr lang="en-US" sz="1700" dirty="0"/>
+          </a:p>
+          <a:p>
+            <a:pPr algn="l" lvl="1" marL="685800" indent="-342900">
+              <a:spcAft>
+                <a:spcPts val="400"/>
+              </a:spcAft>
+              <a:buSzPct val="100000"/>
+              <a:buChar char="▪"/>
+            </a:pPr>
+            <a:r>
+              <a:rPr lang="en-US" sz="1450" dirty="0">
+                <a:solidFill>
+                  <a:srgbClr val="595959"/>
+                </a:solidFill>
+              </a:rPr>
+              <a:t>The class difference is a whole-peak property, not a 170 bp one.</a:t>
+            </a:r>
+            <a:endParaRPr lang="en-US" sz="1700" dirty="0"/>
+          </a:p>
+          <a:p>
+            <a:pPr algn="l" lvl="1" marL="685800" indent="-342900">
+              <a:spcAft>
+                <a:spcPts val="400"/>
+              </a:spcAft>
+              <a:buSzPct val="100000"/>
+              <a:buChar char="▪"/>
+            </a:pPr>
+            <a:r>
+              <a:rPr lang="en-US" sz="1450" dirty="0">
+                <a:solidFill>
+                  <a:srgbClr val="595959"/>
+                </a:solidFill>
+              </a:rPr>
+              <a:t>Within Dynamic, the AP-1-LOSING sites are the ones that are sequence-different, with age and with exercise alike; the gaining ones look like Stable. Direction, not stimulus.</a:t>
+            </a:r>
+            <a:endParaRPr lang="en-US" sz="1700" dirty="0"/>
+          </a:p>
+          <a:p>
+            <a:pPr algn="l" lvl="1" marL="685800" indent="-342900">
+              <a:spcAft>
+                <a:spcPts val="400"/>
+              </a:spcAft>
+              <a:buSzPct val="100000"/>
+              <a:buChar char="▪"/>
+            </a:pPr>
+            <a:r>
+              <a:rPr lang="en-US" sz="1450" dirty="0">
+                <a:solidFill>
+                  <a:srgbClr val="595959"/>
+                </a:solidFill>
+              </a:rPr>
+              <a:t>Unprompted, AlphaGenome makes the AP-1 core the most important 10 bp in over half of all sites — equally in both classes. The classes differ in how much of the dependence sits there, not in whether AP-1 leads.</a:t>
+            </a:r>
+            <a:endParaRPr lang="en-US" sz="1700" dirty="0"/>
+          </a:p>
+          <a:p>
+            <a:pPr algn="l" lvl="1" marL="685800" indent="-342900">
+              <a:spcAft>
+                <a:spcPts val="400"/>
+              </a:spcAft>
+              <a:buSzPct val="100000"/>
+              <a:buChar char="▪"/>
+            </a:pPr>
+            <a:r>
+              <a:rPr lang="en-US" sz="1450" dirty="0">
+                <a:solidFill>
+                  <a:srgbClr val="595959"/>
+                </a:solidFill>
+              </a:rPr>
+              <a:t>Dynamic sites spread their dependence slightly wider, and it survives accessibility matching (33.1% vs 31.3% within ±25 bp, P = 0.006) — the sequence-model version of “attention is more distributed at dynamic enhancers”.</a:t>
+            </a:r>
+            <a:endParaRPr lang="en-US" sz="1700" dirty="0"/>
+          </a:p>
+          <a:p>
+            <a:pPr algn="l" marL="342900" indent="-342900">
+              <a:spcBef>
+                <a:spcPts val="1100"/>
+              </a:spcBef>
+              <a:spcAft>
+                <a:spcPts val="300"/>
+              </a:spcAft>
+              <a:buSzPct val="100000"/>
+              <a:buChar char="•"/>
+            </a:pPr>
+            <a:r>
+              <a:rPr lang="en-US" sz="1700" b="1" dirty="0">
+                <a:solidFill>
+                  <a:srgbClr val="111111"/>
+                </a:solidFill>
+              </a:rPr>
+              <a:t>Keep off the slides</a:t>
+            </a:r>
+            <a:endParaRPr lang="en-US" sz="1700" dirty="0"/>
+          </a:p>
+          <a:p>
+            <a:pPr algn="l" lvl="1" marL="685800" indent="-342900">
+              <a:spcAft>
+                <a:spcPts val="400"/>
+              </a:spcAft>
+              <a:buSzPct val="100000"/>
+              <a:buChar char="▪"/>
+            </a:pPr>
+            <a:r>
+              <a:rPr lang="en-US" sz="1450" dirty="0">
+                <a:solidFill>
+                  <a:srgbClr val="595959"/>
+                </a:solidFill>
+              </a:rPr>
+              <a:t>Our in-situ 170 bp shuffle costs Stable sites more (−2.51 vs −1.96, p = 4e-40), the opposite of the MPRA flank result. Different assay — episomal activity vs chromatin accessibility — but it reads as a contradiction.</a:t>
+            </a:r>
+            <a:endParaRPr lang="en-US" sz="1700" dirty="0"/>
+          </a:p>
+        </p:txBody>
+      </p:sp>
+      <p:sp>
+        <p:nvSpPr>
+          <p:cNvPr id="25" name="Slide Number Placeholder 0"/>
+          <p:cNvSpPr>
+            <a:spLocks noGrp="1"/>
+          </p:cNvSpPr>
+          <p:nvPr>
+            <p:ph type="sldNum" sz="quarter" idx="4294967295"/>
+          </p:nvPr>
+        </p:nvSpPr>
+        <p:spPr>
+          <a:xfrm>
+            <a:off x="11658600" y="6446520"/>
+            <a:ext cx="800000" cy="300000"/>
+          </a:xfrm>
+          <a:prstGeom prst="rect">
+            <a:avLst/>
+          </a:prstGeom>
+          <a:extLst>
+            <a:ext uri="{C572A759-6A51-4108-AA02-DFA0A04FC94B}">
+              <ma14:wrappingTextBoxFlag xmlns:ma14="http://schemas.microsoft.com/office/mac/drawingml/2011/main" val="0"/>
+            </a:ext>
+          </a:extLst>
+        </p:spPr>
+        <p:txBody>
+          <a:bodyPr/>
+          <a:lstStyle>
+            <a:lvl1pPr>
+              <a:defRPr sz="1000">
+                <a:solidFill>
+                  <a:srgbClr val="A6A6A6"/>
+                </a:solidFill>
+              </a:defRPr>
+            </a:lvl1pPr>
+          </a:lstStyle>
+          <a:p>
+            <a:pPr algn="l"/>
+            <a:fld id="{F7021451-1387-4CA6-816F-3879F97B5CBC}" type="slidenum">
+              <a:rPr b="0" lang="en-US"/>
+              <a:t>20</a:t>
             </a:fld>
             <a:endParaRPr lang="en-US"/>
           </a:p>

</xml_diff>